<commit_message>
fix: update example files
</commit_message>
<xml_diff>
--- a/example/example2.pptx
+++ b/example/example2.pptx
@@ -2,18 +2,18 @@
 <file path=ppt/presentation.xml><?xml version="1.0" encoding="utf-8"?>
 <p:presentation xmlns:a="http://schemas.openxmlformats.org/drawingml/2006/main" xmlns:r="http://schemas.openxmlformats.org/officeDocument/2006/relationships" xmlns:p="http://schemas.openxmlformats.org/presentationml/2006/main" saveSubsetFonts="1" autoCompressPictures="0">
   <p:sldMasterIdLst>
-    <p:sldMasterId id="2147483648" r:id="rId1"/>
+    <p:sldMasterId id="2147483660" r:id="rId1"/>
   </p:sldMasterIdLst>
   <p:sldIdLst>
     <p:sldId id="266" r:id="rId2"/>
   </p:sldIdLst>
-  <p:sldSz cx="12192000" cy="6858000"/>
+  <p:sldSz cx="9906000" cy="6858000" type="A4"/>
   <p:notesSz cx="6858000" cy="9144000"/>
   <p:defaultTextStyle>
     <a:defPPr>
-      <a:defRPr lang="en-TH"/>
+      <a:defRPr lang="en-US"/>
     </a:defPPr>
-    <a:lvl1pPr marL="0" algn="l" defTabSz="914400" rtl="0" eaLnBrk="1" latinLnBrk="0" hangingPunct="1">
+    <a:lvl1pPr marL="0" algn="l" defTabSz="457200" rtl="0" eaLnBrk="1" latinLnBrk="0" hangingPunct="1">
       <a:defRPr sz="1800" kern="1200">
         <a:solidFill>
           <a:schemeClr val="tx1"/>
@@ -23,7 +23,7 @@
         <a:cs typeface="+mn-cs"/>
       </a:defRPr>
     </a:lvl1pPr>
-    <a:lvl2pPr marL="457200" algn="l" defTabSz="914400" rtl="0" eaLnBrk="1" latinLnBrk="0" hangingPunct="1">
+    <a:lvl2pPr marL="457200" algn="l" defTabSz="457200" rtl="0" eaLnBrk="1" latinLnBrk="0" hangingPunct="1">
       <a:defRPr sz="1800" kern="1200">
         <a:solidFill>
           <a:schemeClr val="tx1"/>
@@ -33,7 +33,7 @@
         <a:cs typeface="+mn-cs"/>
       </a:defRPr>
     </a:lvl2pPr>
-    <a:lvl3pPr marL="914400" algn="l" defTabSz="914400" rtl="0" eaLnBrk="1" latinLnBrk="0" hangingPunct="1">
+    <a:lvl3pPr marL="914400" algn="l" defTabSz="457200" rtl="0" eaLnBrk="1" latinLnBrk="0" hangingPunct="1">
       <a:defRPr sz="1800" kern="1200">
         <a:solidFill>
           <a:schemeClr val="tx1"/>
@@ -43,7 +43,7 @@
         <a:cs typeface="+mn-cs"/>
       </a:defRPr>
     </a:lvl3pPr>
-    <a:lvl4pPr marL="1371600" algn="l" defTabSz="914400" rtl="0" eaLnBrk="1" latinLnBrk="0" hangingPunct="1">
+    <a:lvl4pPr marL="1371600" algn="l" defTabSz="457200" rtl="0" eaLnBrk="1" latinLnBrk="0" hangingPunct="1">
       <a:defRPr sz="1800" kern="1200">
         <a:solidFill>
           <a:schemeClr val="tx1"/>
@@ -53,7 +53,7 @@
         <a:cs typeface="+mn-cs"/>
       </a:defRPr>
     </a:lvl4pPr>
-    <a:lvl5pPr marL="1828800" algn="l" defTabSz="914400" rtl="0" eaLnBrk="1" latinLnBrk="0" hangingPunct="1">
+    <a:lvl5pPr marL="1828800" algn="l" defTabSz="457200" rtl="0" eaLnBrk="1" latinLnBrk="0" hangingPunct="1">
       <a:defRPr sz="1800" kern="1200">
         <a:solidFill>
           <a:schemeClr val="tx1"/>
@@ -63,7 +63,7 @@
         <a:cs typeface="+mn-cs"/>
       </a:defRPr>
     </a:lvl5pPr>
-    <a:lvl6pPr marL="2286000" algn="l" defTabSz="914400" rtl="0" eaLnBrk="1" latinLnBrk="0" hangingPunct="1">
+    <a:lvl6pPr marL="2286000" algn="l" defTabSz="457200" rtl="0" eaLnBrk="1" latinLnBrk="0" hangingPunct="1">
       <a:defRPr sz="1800" kern="1200">
         <a:solidFill>
           <a:schemeClr val="tx1"/>
@@ -73,7 +73,7 @@
         <a:cs typeface="+mn-cs"/>
       </a:defRPr>
     </a:lvl6pPr>
-    <a:lvl7pPr marL="2743200" algn="l" defTabSz="914400" rtl="0" eaLnBrk="1" latinLnBrk="0" hangingPunct="1">
+    <a:lvl7pPr marL="2743200" algn="l" defTabSz="457200" rtl="0" eaLnBrk="1" latinLnBrk="0" hangingPunct="1">
       <a:defRPr sz="1800" kern="1200">
         <a:solidFill>
           <a:schemeClr val="tx1"/>
@@ -83,7 +83,7 @@
         <a:cs typeface="+mn-cs"/>
       </a:defRPr>
     </a:lvl7pPr>
-    <a:lvl8pPr marL="3200400" algn="l" defTabSz="914400" rtl="0" eaLnBrk="1" latinLnBrk="0" hangingPunct="1">
+    <a:lvl8pPr marL="3200400" algn="l" defTabSz="457200" rtl="0" eaLnBrk="1" latinLnBrk="0" hangingPunct="1">
       <a:defRPr sz="1800" kern="1200">
         <a:solidFill>
           <a:schemeClr val="tx1"/>
@@ -93,7 +93,7 @@
         <a:cs typeface="+mn-cs"/>
       </a:defRPr>
     </a:lvl8pPr>
-    <a:lvl9pPr marL="3657600" algn="l" defTabSz="914400" rtl="0" eaLnBrk="1" latinLnBrk="0" hangingPunct="1">
+    <a:lvl9pPr marL="3657600" algn="l" defTabSz="457200" rtl="0" eaLnBrk="1" latinLnBrk="0" hangingPunct="1">
       <a:defRPr sz="1800" kern="1200">
         <a:solidFill>
           <a:schemeClr val="tx1"/>
@@ -131,13 +131,7 @@
       </p:grpSpPr>
       <p:sp>
         <p:nvSpPr>
-          <p:cNvPr id="2" name="Title 1">
-            <a:extLst>
-              <a:ext uri="{FF2B5EF4-FFF2-40B4-BE49-F238E27FC236}">
-                <a16:creationId xmlns:a16="http://schemas.microsoft.com/office/drawing/2014/main" id="{7A208B67-A263-048B-734D-2B5D10CB1592}"/>
-              </a:ext>
-            </a:extLst>
-          </p:cNvPr>
+          <p:cNvPr id="2" name="Title 1"/>
           <p:cNvSpPr>
             <a:spLocks noGrp="1"/>
           </p:cNvSpPr>
@@ -147,8 +141,8 @@
         </p:nvSpPr>
         <p:spPr>
           <a:xfrm>
-            <a:off x="1524000" y="1122363"/>
-            <a:ext cx="9144000" cy="2387600"/>
+            <a:off x="742950" y="1122363"/>
+            <a:ext cx="8420100" cy="2387600"/>
           </a:xfrm>
         </p:spPr>
         <p:txBody>
@@ -163,19 +157,13 @@
               <a:rPr lang="en-US"/>
               <a:t>Click to edit Master title style</a:t>
             </a:r>
-            <a:endParaRPr lang="en-TH"/>
-          </a:p>
-        </p:txBody>
-      </p:sp>
-      <p:sp>
-        <p:nvSpPr>
-          <p:cNvPr id="3" name="Subtitle 2">
-            <a:extLst>
-              <a:ext uri="{FF2B5EF4-FFF2-40B4-BE49-F238E27FC236}">
-                <a16:creationId xmlns:a16="http://schemas.microsoft.com/office/drawing/2014/main" id="{7B124F35-C0C2-6EDB-DEFF-5D6BB9E7E33E}"/>
-              </a:ext>
-            </a:extLst>
-          </p:cNvPr>
+            <a:endParaRPr lang="en-US" dirty="0"/>
+          </a:p>
+        </p:txBody>
+      </p:sp>
+      <p:sp>
+        <p:nvSpPr>
+          <p:cNvPr id="3" name="Subtitle 2"/>
           <p:cNvSpPr>
             <a:spLocks noGrp="1"/>
           </p:cNvSpPr>
@@ -185,8 +173,8 @@
         </p:nvSpPr>
         <p:spPr>
           <a:xfrm>
-            <a:off x="1524000" y="3602038"/>
-            <a:ext cx="9144000" cy="1655762"/>
+            <a:off x="1238250" y="3602038"/>
+            <a:ext cx="7429500" cy="1655762"/>
           </a:xfrm>
         </p:spPr>
         <p:txBody>
@@ -234,19 +222,13 @@
               <a:rPr lang="en-US"/>
               <a:t>Click to edit Master subtitle style</a:t>
             </a:r>
-            <a:endParaRPr lang="en-TH"/>
-          </a:p>
-        </p:txBody>
-      </p:sp>
-      <p:sp>
-        <p:nvSpPr>
-          <p:cNvPr id="4" name="Date Placeholder 3">
-            <a:extLst>
-              <a:ext uri="{FF2B5EF4-FFF2-40B4-BE49-F238E27FC236}">
-                <a16:creationId xmlns:a16="http://schemas.microsoft.com/office/drawing/2014/main" id="{6C65C9F1-89A9-2E6B-C88B-1EE2889AF3AE}"/>
-              </a:ext>
-            </a:extLst>
-          </p:cNvPr>
+            <a:endParaRPr lang="en-US" dirty="0"/>
+          </a:p>
+        </p:txBody>
+      </p:sp>
+      <p:sp>
+        <p:nvSpPr>
+          <p:cNvPr id="4" name="Date Placeholder 3"/>
           <p:cNvSpPr>
             <a:spLocks noGrp="1"/>
           </p:cNvSpPr>
@@ -269,13 +251,7 @@
       </p:sp>
       <p:sp>
         <p:nvSpPr>
-          <p:cNvPr id="5" name="Footer Placeholder 4">
-            <a:extLst>
-              <a:ext uri="{FF2B5EF4-FFF2-40B4-BE49-F238E27FC236}">
-                <a16:creationId xmlns:a16="http://schemas.microsoft.com/office/drawing/2014/main" id="{20AEF4E8-BCB6-72EC-C263-9AE2617F2E51}"/>
-              </a:ext>
-            </a:extLst>
-          </p:cNvPr>
+          <p:cNvPr id="5" name="Footer Placeholder 4"/>
           <p:cNvSpPr>
             <a:spLocks noGrp="1"/>
           </p:cNvSpPr>
@@ -294,13 +270,7 @@
       </p:sp>
       <p:sp>
         <p:nvSpPr>
-          <p:cNvPr id="6" name="Slide Number Placeholder 5">
-            <a:extLst>
-              <a:ext uri="{FF2B5EF4-FFF2-40B4-BE49-F238E27FC236}">
-                <a16:creationId xmlns:a16="http://schemas.microsoft.com/office/drawing/2014/main" id="{B64D169A-C9B3-2D9D-DE42-E30BCCE3EAA3}"/>
-              </a:ext>
-            </a:extLst>
-          </p:cNvPr>
+          <p:cNvPr id="6" name="Slide Number Placeholder 5"/>
           <p:cNvSpPr>
             <a:spLocks noGrp="1"/>
           </p:cNvSpPr>
@@ -324,7 +294,7 @@
     </p:spTree>
     <p:extLst>
       <p:ext uri="{BB962C8B-B14F-4D97-AF65-F5344CB8AC3E}">
-        <p14:creationId xmlns:p14="http://schemas.microsoft.com/office/powerpoint/2010/main" val="2828201835"/>
+        <p14:creationId xmlns:p14="http://schemas.microsoft.com/office/powerpoint/2010/main" val="3700077314"/>
       </p:ext>
     </p:extLst>
   </p:cSld>
@@ -353,13 +323,7 @@
       </p:grpSpPr>
       <p:sp>
         <p:nvSpPr>
-          <p:cNvPr id="2" name="Title 1">
-            <a:extLst>
-              <a:ext uri="{FF2B5EF4-FFF2-40B4-BE49-F238E27FC236}">
-                <a16:creationId xmlns:a16="http://schemas.microsoft.com/office/drawing/2014/main" id="{68DD5BFF-45F5-1F5D-4EC6-188E092FC894}"/>
-              </a:ext>
-            </a:extLst>
-          </p:cNvPr>
+          <p:cNvPr id="2" name="Title 1"/>
           <p:cNvSpPr>
             <a:spLocks noGrp="1"/>
           </p:cNvSpPr>
@@ -376,19 +340,13 @@
               <a:rPr lang="en-US"/>
               <a:t>Click to edit Master title style</a:t>
             </a:r>
-            <a:endParaRPr lang="en-TH"/>
-          </a:p>
-        </p:txBody>
-      </p:sp>
-      <p:sp>
-        <p:nvSpPr>
-          <p:cNvPr id="3" name="Vertical Text Placeholder 2">
-            <a:extLst>
-              <a:ext uri="{FF2B5EF4-FFF2-40B4-BE49-F238E27FC236}">
-                <a16:creationId xmlns:a16="http://schemas.microsoft.com/office/drawing/2014/main" id="{6BA49131-826F-464D-BE85-8A8A0AA6AC61}"/>
-              </a:ext>
-            </a:extLst>
-          </p:cNvPr>
+            <a:endParaRPr lang="en-US" dirty="0"/>
+          </a:p>
+        </p:txBody>
+      </p:sp>
+      <p:sp>
+        <p:nvSpPr>
+          <p:cNvPr id="3" name="Vertical Text Placeholder 2"/>
           <p:cNvSpPr>
             <a:spLocks noGrp="1"/>
           </p:cNvSpPr>
@@ -434,19 +392,13 @@
               <a:rPr lang="en-US"/>
               <a:t>Fifth level</a:t>
             </a:r>
-            <a:endParaRPr lang="en-TH"/>
-          </a:p>
-        </p:txBody>
-      </p:sp>
-      <p:sp>
-        <p:nvSpPr>
-          <p:cNvPr id="4" name="Date Placeholder 3">
-            <a:extLst>
-              <a:ext uri="{FF2B5EF4-FFF2-40B4-BE49-F238E27FC236}">
-                <a16:creationId xmlns:a16="http://schemas.microsoft.com/office/drawing/2014/main" id="{0EC8CCFF-CC28-F9D3-5E81-480CF693D36D}"/>
-              </a:ext>
-            </a:extLst>
-          </p:cNvPr>
+            <a:endParaRPr lang="en-US" dirty="0"/>
+          </a:p>
+        </p:txBody>
+      </p:sp>
+      <p:sp>
+        <p:nvSpPr>
+          <p:cNvPr id="4" name="Date Placeholder 3"/>
           <p:cNvSpPr>
             <a:spLocks noGrp="1"/>
           </p:cNvSpPr>
@@ -469,13 +421,7 @@
       </p:sp>
       <p:sp>
         <p:nvSpPr>
-          <p:cNvPr id="5" name="Footer Placeholder 4">
-            <a:extLst>
-              <a:ext uri="{FF2B5EF4-FFF2-40B4-BE49-F238E27FC236}">
-                <a16:creationId xmlns:a16="http://schemas.microsoft.com/office/drawing/2014/main" id="{57D24E5E-E1EB-0081-6CD7-84F08DE2BE09}"/>
-              </a:ext>
-            </a:extLst>
-          </p:cNvPr>
+          <p:cNvPr id="5" name="Footer Placeholder 4"/>
           <p:cNvSpPr>
             <a:spLocks noGrp="1"/>
           </p:cNvSpPr>
@@ -494,13 +440,7 @@
       </p:sp>
       <p:sp>
         <p:nvSpPr>
-          <p:cNvPr id="6" name="Slide Number Placeholder 5">
-            <a:extLst>
-              <a:ext uri="{FF2B5EF4-FFF2-40B4-BE49-F238E27FC236}">
-                <a16:creationId xmlns:a16="http://schemas.microsoft.com/office/drawing/2014/main" id="{3C963E05-269D-DB49-1618-CA656ECA39BD}"/>
-              </a:ext>
-            </a:extLst>
-          </p:cNvPr>
+          <p:cNvPr id="6" name="Slide Number Placeholder 5"/>
           <p:cNvSpPr>
             <a:spLocks noGrp="1"/>
           </p:cNvSpPr>
@@ -524,7 +464,7 @@
     </p:spTree>
     <p:extLst>
       <p:ext uri="{BB962C8B-B14F-4D97-AF65-F5344CB8AC3E}">
-        <p14:creationId xmlns:p14="http://schemas.microsoft.com/office/powerpoint/2010/main" val="2710032265"/>
+        <p14:creationId xmlns:p14="http://schemas.microsoft.com/office/powerpoint/2010/main" val="3971855877"/>
       </p:ext>
     </p:extLst>
   </p:cSld>
@@ -553,13 +493,7 @@
       </p:grpSpPr>
       <p:sp>
         <p:nvSpPr>
-          <p:cNvPr id="2" name="Vertical Title 1">
-            <a:extLst>
-              <a:ext uri="{FF2B5EF4-FFF2-40B4-BE49-F238E27FC236}">
-                <a16:creationId xmlns:a16="http://schemas.microsoft.com/office/drawing/2014/main" id="{AB58088D-DF03-3955-A523-1F795D47B1EA}"/>
-              </a:ext>
-            </a:extLst>
-          </p:cNvPr>
+          <p:cNvPr id="2" name="Vertical Title 1"/>
           <p:cNvSpPr>
             <a:spLocks noGrp="1"/>
           </p:cNvSpPr>
@@ -569,8 +503,8 @@
         </p:nvSpPr>
         <p:spPr>
           <a:xfrm>
-            <a:off x="8724900" y="365125"/>
-            <a:ext cx="2628900" cy="5811838"/>
+            <a:off x="7088982" y="365125"/>
+            <a:ext cx="2135981" cy="5811838"/>
           </a:xfrm>
         </p:spPr>
         <p:txBody>
@@ -581,19 +515,13 @@
               <a:rPr lang="en-US"/>
               <a:t>Click to edit Master title style</a:t>
             </a:r>
-            <a:endParaRPr lang="en-TH"/>
-          </a:p>
-        </p:txBody>
-      </p:sp>
-      <p:sp>
-        <p:nvSpPr>
-          <p:cNvPr id="3" name="Vertical Text Placeholder 2">
-            <a:extLst>
-              <a:ext uri="{FF2B5EF4-FFF2-40B4-BE49-F238E27FC236}">
-                <a16:creationId xmlns:a16="http://schemas.microsoft.com/office/drawing/2014/main" id="{F656F010-3A02-BF96-A66F-7566F14C0FA6}"/>
-              </a:ext>
-            </a:extLst>
-          </p:cNvPr>
+            <a:endParaRPr lang="en-US" dirty="0"/>
+          </a:p>
+        </p:txBody>
+      </p:sp>
+      <p:sp>
+        <p:nvSpPr>
+          <p:cNvPr id="3" name="Vertical Text Placeholder 2"/>
           <p:cNvSpPr>
             <a:spLocks noGrp="1"/>
           </p:cNvSpPr>
@@ -603,8 +531,8 @@
         </p:nvSpPr>
         <p:spPr>
           <a:xfrm>
-            <a:off x="838200" y="365125"/>
-            <a:ext cx="7734300" cy="5811838"/>
+            <a:off x="681038" y="365125"/>
+            <a:ext cx="6284119" cy="5811838"/>
           </a:xfrm>
         </p:spPr>
         <p:txBody>
@@ -644,19 +572,13 @@
               <a:rPr lang="en-US"/>
               <a:t>Fifth level</a:t>
             </a:r>
-            <a:endParaRPr lang="en-TH"/>
-          </a:p>
-        </p:txBody>
-      </p:sp>
-      <p:sp>
-        <p:nvSpPr>
-          <p:cNvPr id="4" name="Date Placeholder 3">
-            <a:extLst>
-              <a:ext uri="{FF2B5EF4-FFF2-40B4-BE49-F238E27FC236}">
-                <a16:creationId xmlns:a16="http://schemas.microsoft.com/office/drawing/2014/main" id="{9BBF6217-E475-D6D1-0FC0-7E03AAEF25D3}"/>
-              </a:ext>
-            </a:extLst>
-          </p:cNvPr>
+            <a:endParaRPr lang="en-US" dirty="0"/>
+          </a:p>
+        </p:txBody>
+      </p:sp>
+      <p:sp>
+        <p:nvSpPr>
+          <p:cNvPr id="4" name="Date Placeholder 3"/>
           <p:cNvSpPr>
             <a:spLocks noGrp="1"/>
           </p:cNvSpPr>
@@ -679,13 +601,7 @@
       </p:sp>
       <p:sp>
         <p:nvSpPr>
-          <p:cNvPr id="5" name="Footer Placeholder 4">
-            <a:extLst>
-              <a:ext uri="{FF2B5EF4-FFF2-40B4-BE49-F238E27FC236}">
-                <a16:creationId xmlns:a16="http://schemas.microsoft.com/office/drawing/2014/main" id="{786189AB-EF78-F510-83BC-7F085EC53D58}"/>
-              </a:ext>
-            </a:extLst>
-          </p:cNvPr>
+          <p:cNvPr id="5" name="Footer Placeholder 4"/>
           <p:cNvSpPr>
             <a:spLocks noGrp="1"/>
           </p:cNvSpPr>
@@ -704,13 +620,7 @@
       </p:sp>
       <p:sp>
         <p:nvSpPr>
-          <p:cNvPr id="6" name="Slide Number Placeholder 5">
-            <a:extLst>
-              <a:ext uri="{FF2B5EF4-FFF2-40B4-BE49-F238E27FC236}">
-                <a16:creationId xmlns:a16="http://schemas.microsoft.com/office/drawing/2014/main" id="{547BF276-056B-FB56-22F2-3BE71F90F2C2}"/>
-              </a:ext>
-            </a:extLst>
-          </p:cNvPr>
+          <p:cNvPr id="6" name="Slide Number Placeholder 5"/>
           <p:cNvSpPr>
             <a:spLocks noGrp="1"/>
           </p:cNvSpPr>
@@ -734,7 +644,7 @@
     </p:spTree>
     <p:extLst>
       <p:ext uri="{BB962C8B-B14F-4D97-AF65-F5344CB8AC3E}">
-        <p14:creationId xmlns:p14="http://schemas.microsoft.com/office/powerpoint/2010/main" val="3614553497"/>
+        <p14:creationId xmlns:p14="http://schemas.microsoft.com/office/powerpoint/2010/main" val="4154977566"/>
       </p:ext>
     </p:extLst>
   </p:cSld>
@@ -763,13 +673,7 @@
       </p:grpSpPr>
       <p:sp>
         <p:nvSpPr>
-          <p:cNvPr id="2" name="Title 1">
-            <a:extLst>
-              <a:ext uri="{FF2B5EF4-FFF2-40B4-BE49-F238E27FC236}">
-                <a16:creationId xmlns:a16="http://schemas.microsoft.com/office/drawing/2014/main" id="{79318E1C-1DBC-6E8A-D216-A8C867218141}"/>
-              </a:ext>
-            </a:extLst>
-          </p:cNvPr>
+          <p:cNvPr id="2" name="Title 1"/>
           <p:cNvSpPr>
             <a:spLocks noGrp="1"/>
           </p:cNvSpPr>
@@ -786,19 +690,13 @@
               <a:rPr lang="en-US"/>
               <a:t>Click to edit Master title style</a:t>
             </a:r>
-            <a:endParaRPr lang="en-TH"/>
-          </a:p>
-        </p:txBody>
-      </p:sp>
-      <p:sp>
-        <p:nvSpPr>
-          <p:cNvPr id="3" name="Content Placeholder 2">
-            <a:extLst>
-              <a:ext uri="{FF2B5EF4-FFF2-40B4-BE49-F238E27FC236}">
-                <a16:creationId xmlns:a16="http://schemas.microsoft.com/office/drawing/2014/main" id="{7DB18E5B-53C7-ED72-8BBA-1404C2CBC7EC}"/>
-              </a:ext>
-            </a:extLst>
-          </p:cNvPr>
+            <a:endParaRPr lang="en-US" dirty="0"/>
+          </a:p>
+        </p:txBody>
+      </p:sp>
+      <p:sp>
+        <p:nvSpPr>
+          <p:cNvPr id="3" name="Content Placeholder 2"/>
           <p:cNvSpPr>
             <a:spLocks noGrp="1"/>
           </p:cNvSpPr>
@@ -844,19 +742,13 @@
               <a:rPr lang="en-US"/>
               <a:t>Fifth level</a:t>
             </a:r>
-            <a:endParaRPr lang="en-TH"/>
-          </a:p>
-        </p:txBody>
-      </p:sp>
-      <p:sp>
-        <p:nvSpPr>
-          <p:cNvPr id="4" name="Date Placeholder 3">
-            <a:extLst>
-              <a:ext uri="{FF2B5EF4-FFF2-40B4-BE49-F238E27FC236}">
-                <a16:creationId xmlns:a16="http://schemas.microsoft.com/office/drawing/2014/main" id="{EA2B2299-A1D8-D4F3-56AC-308F8A7E1D16}"/>
-              </a:ext>
-            </a:extLst>
-          </p:cNvPr>
+            <a:endParaRPr lang="en-US" dirty="0"/>
+          </a:p>
+        </p:txBody>
+      </p:sp>
+      <p:sp>
+        <p:nvSpPr>
+          <p:cNvPr id="4" name="Date Placeholder 3"/>
           <p:cNvSpPr>
             <a:spLocks noGrp="1"/>
           </p:cNvSpPr>
@@ -879,13 +771,7 @@
       </p:sp>
       <p:sp>
         <p:nvSpPr>
-          <p:cNvPr id="5" name="Footer Placeholder 4">
-            <a:extLst>
-              <a:ext uri="{FF2B5EF4-FFF2-40B4-BE49-F238E27FC236}">
-                <a16:creationId xmlns:a16="http://schemas.microsoft.com/office/drawing/2014/main" id="{3C94B60D-D6ED-E7CA-6385-CFAAF37E5F50}"/>
-              </a:ext>
-            </a:extLst>
-          </p:cNvPr>
+          <p:cNvPr id="5" name="Footer Placeholder 4"/>
           <p:cNvSpPr>
             <a:spLocks noGrp="1"/>
           </p:cNvSpPr>
@@ -904,13 +790,7 @@
       </p:sp>
       <p:sp>
         <p:nvSpPr>
-          <p:cNvPr id="6" name="Slide Number Placeholder 5">
-            <a:extLst>
-              <a:ext uri="{FF2B5EF4-FFF2-40B4-BE49-F238E27FC236}">
-                <a16:creationId xmlns:a16="http://schemas.microsoft.com/office/drawing/2014/main" id="{D480B343-738C-DB62-5C4A-60F6AA80B272}"/>
-              </a:ext>
-            </a:extLst>
-          </p:cNvPr>
+          <p:cNvPr id="6" name="Slide Number Placeholder 5"/>
           <p:cNvSpPr>
             <a:spLocks noGrp="1"/>
           </p:cNvSpPr>
@@ -934,7 +814,7 @@
     </p:spTree>
     <p:extLst>
       <p:ext uri="{BB962C8B-B14F-4D97-AF65-F5344CB8AC3E}">
-        <p14:creationId xmlns:p14="http://schemas.microsoft.com/office/powerpoint/2010/main" val="562745017"/>
+        <p14:creationId xmlns:p14="http://schemas.microsoft.com/office/powerpoint/2010/main" val="2233131134"/>
       </p:ext>
     </p:extLst>
   </p:cSld>
@@ -963,13 +843,7 @@
       </p:grpSpPr>
       <p:sp>
         <p:nvSpPr>
-          <p:cNvPr id="2" name="Title 1">
-            <a:extLst>
-              <a:ext uri="{FF2B5EF4-FFF2-40B4-BE49-F238E27FC236}">
-                <a16:creationId xmlns:a16="http://schemas.microsoft.com/office/drawing/2014/main" id="{F945D1D0-B6F5-F512-4F3B-0129584AA9A3}"/>
-              </a:ext>
-            </a:extLst>
-          </p:cNvPr>
+          <p:cNvPr id="2" name="Title 1"/>
           <p:cNvSpPr>
             <a:spLocks noGrp="1"/>
           </p:cNvSpPr>
@@ -979,8 +853,8 @@
         </p:nvSpPr>
         <p:spPr>
           <a:xfrm>
-            <a:off x="831850" y="1709738"/>
-            <a:ext cx="10515600" cy="2852737"/>
+            <a:off x="675879" y="1709740"/>
+            <a:ext cx="8543925" cy="2852737"/>
           </a:xfrm>
         </p:spPr>
         <p:txBody>
@@ -995,19 +869,13 @@
               <a:rPr lang="en-US"/>
               <a:t>Click to edit Master title style</a:t>
             </a:r>
-            <a:endParaRPr lang="en-TH"/>
-          </a:p>
-        </p:txBody>
-      </p:sp>
-      <p:sp>
-        <p:nvSpPr>
-          <p:cNvPr id="3" name="Text Placeholder 2">
-            <a:extLst>
-              <a:ext uri="{FF2B5EF4-FFF2-40B4-BE49-F238E27FC236}">
-                <a16:creationId xmlns:a16="http://schemas.microsoft.com/office/drawing/2014/main" id="{0AA614FD-C09E-9B53-2A89-1B98FE629BF7}"/>
-              </a:ext>
-            </a:extLst>
-          </p:cNvPr>
+            <a:endParaRPr lang="en-US" dirty="0"/>
+          </a:p>
+        </p:txBody>
+      </p:sp>
+      <p:sp>
+        <p:nvSpPr>
+          <p:cNvPr id="3" name="Text Placeholder 2"/>
           <p:cNvSpPr>
             <a:spLocks noGrp="1"/>
           </p:cNvSpPr>
@@ -1017,8 +885,8 @@
         </p:nvSpPr>
         <p:spPr>
           <a:xfrm>
-            <a:off x="831850" y="4589463"/>
-            <a:ext cx="10515600" cy="1500187"/>
+            <a:off x="675879" y="4589465"/>
+            <a:ext cx="8543925" cy="1500187"/>
           </a:xfrm>
         </p:spPr>
         <p:txBody>
@@ -1126,13 +994,7 @@
       </p:sp>
       <p:sp>
         <p:nvSpPr>
-          <p:cNvPr id="4" name="Date Placeholder 3">
-            <a:extLst>
-              <a:ext uri="{FF2B5EF4-FFF2-40B4-BE49-F238E27FC236}">
-                <a16:creationId xmlns:a16="http://schemas.microsoft.com/office/drawing/2014/main" id="{AFF78DDB-BC3D-0EF0-DB66-93E8F32CE858}"/>
-              </a:ext>
-            </a:extLst>
-          </p:cNvPr>
+          <p:cNvPr id="4" name="Date Placeholder 3"/>
           <p:cNvSpPr>
             <a:spLocks noGrp="1"/>
           </p:cNvSpPr>
@@ -1155,13 +1017,7 @@
       </p:sp>
       <p:sp>
         <p:nvSpPr>
-          <p:cNvPr id="5" name="Footer Placeholder 4">
-            <a:extLst>
-              <a:ext uri="{FF2B5EF4-FFF2-40B4-BE49-F238E27FC236}">
-                <a16:creationId xmlns:a16="http://schemas.microsoft.com/office/drawing/2014/main" id="{341DAB0C-D9A1-5A32-A5AC-F20F23586DEB}"/>
-              </a:ext>
-            </a:extLst>
-          </p:cNvPr>
+          <p:cNvPr id="5" name="Footer Placeholder 4"/>
           <p:cNvSpPr>
             <a:spLocks noGrp="1"/>
           </p:cNvSpPr>
@@ -1180,13 +1036,7 @@
       </p:sp>
       <p:sp>
         <p:nvSpPr>
-          <p:cNvPr id="6" name="Slide Number Placeholder 5">
-            <a:extLst>
-              <a:ext uri="{FF2B5EF4-FFF2-40B4-BE49-F238E27FC236}">
-                <a16:creationId xmlns:a16="http://schemas.microsoft.com/office/drawing/2014/main" id="{29AAB4AC-15B9-8086-7787-DB0D4F123E54}"/>
-              </a:ext>
-            </a:extLst>
-          </p:cNvPr>
+          <p:cNvPr id="6" name="Slide Number Placeholder 5"/>
           <p:cNvSpPr>
             <a:spLocks noGrp="1"/>
           </p:cNvSpPr>
@@ -1210,7 +1060,7 @@
     </p:spTree>
     <p:extLst>
       <p:ext uri="{BB962C8B-B14F-4D97-AF65-F5344CB8AC3E}">
-        <p14:creationId xmlns:p14="http://schemas.microsoft.com/office/powerpoint/2010/main" val="3330343390"/>
+        <p14:creationId xmlns:p14="http://schemas.microsoft.com/office/powerpoint/2010/main" val="2339675218"/>
       </p:ext>
     </p:extLst>
   </p:cSld>
@@ -1239,13 +1089,7 @@
       </p:grpSpPr>
       <p:sp>
         <p:nvSpPr>
-          <p:cNvPr id="2" name="Title 1">
-            <a:extLst>
-              <a:ext uri="{FF2B5EF4-FFF2-40B4-BE49-F238E27FC236}">
-                <a16:creationId xmlns:a16="http://schemas.microsoft.com/office/drawing/2014/main" id="{135CD739-EB0D-FAB4-694E-8B1D36FE346E}"/>
-              </a:ext>
-            </a:extLst>
-          </p:cNvPr>
+          <p:cNvPr id="2" name="Title 1"/>
           <p:cNvSpPr>
             <a:spLocks noGrp="1"/>
           </p:cNvSpPr>
@@ -1262,19 +1106,13 @@
               <a:rPr lang="en-US"/>
               <a:t>Click to edit Master title style</a:t>
             </a:r>
-            <a:endParaRPr lang="en-TH"/>
-          </a:p>
-        </p:txBody>
-      </p:sp>
-      <p:sp>
-        <p:nvSpPr>
-          <p:cNvPr id="3" name="Content Placeholder 2">
-            <a:extLst>
-              <a:ext uri="{FF2B5EF4-FFF2-40B4-BE49-F238E27FC236}">
-                <a16:creationId xmlns:a16="http://schemas.microsoft.com/office/drawing/2014/main" id="{1A6E4CA6-EEE1-1FFA-2FA0-5A9A9E109216}"/>
-              </a:ext>
-            </a:extLst>
-          </p:cNvPr>
+            <a:endParaRPr lang="en-US" dirty="0"/>
+          </a:p>
+        </p:txBody>
+      </p:sp>
+      <p:sp>
+        <p:nvSpPr>
+          <p:cNvPr id="3" name="Content Placeholder 2"/>
           <p:cNvSpPr>
             <a:spLocks noGrp="1"/>
           </p:cNvSpPr>
@@ -1284,8 +1122,8 @@
         </p:nvSpPr>
         <p:spPr>
           <a:xfrm>
-            <a:off x="838200" y="1825625"/>
-            <a:ext cx="5181600" cy="4351338"/>
+            <a:off x="681038" y="1825625"/>
+            <a:ext cx="4210050" cy="4351338"/>
           </a:xfrm>
         </p:spPr>
         <p:txBody>
@@ -1325,19 +1163,13 @@
               <a:rPr lang="en-US"/>
               <a:t>Fifth level</a:t>
             </a:r>
-            <a:endParaRPr lang="en-TH"/>
-          </a:p>
-        </p:txBody>
-      </p:sp>
-      <p:sp>
-        <p:nvSpPr>
-          <p:cNvPr id="4" name="Content Placeholder 3">
-            <a:extLst>
-              <a:ext uri="{FF2B5EF4-FFF2-40B4-BE49-F238E27FC236}">
-                <a16:creationId xmlns:a16="http://schemas.microsoft.com/office/drawing/2014/main" id="{290A3095-4948-6C3A-0DCB-2508EFDD1818}"/>
-              </a:ext>
-            </a:extLst>
-          </p:cNvPr>
+            <a:endParaRPr lang="en-US" dirty="0"/>
+          </a:p>
+        </p:txBody>
+      </p:sp>
+      <p:sp>
+        <p:nvSpPr>
+          <p:cNvPr id="4" name="Content Placeholder 3"/>
           <p:cNvSpPr>
             <a:spLocks noGrp="1"/>
           </p:cNvSpPr>
@@ -1347,8 +1179,8 @@
         </p:nvSpPr>
         <p:spPr>
           <a:xfrm>
-            <a:off x="6172200" y="1825625"/>
-            <a:ext cx="5181600" cy="4351338"/>
+            <a:off x="5014913" y="1825625"/>
+            <a:ext cx="4210050" cy="4351338"/>
           </a:xfrm>
         </p:spPr>
         <p:txBody>
@@ -1388,19 +1220,13 @@
               <a:rPr lang="en-US"/>
               <a:t>Fifth level</a:t>
             </a:r>
-            <a:endParaRPr lang="en-TH"/>
-          </a:p>
-        </p:txBody>
-      </p:sp>
-      <p:sp>
-        <p:nvSpPr>
-          <p:cNvPr id="5" name="Date Placeholder 4">
-            <a:extLst>
-              <a:ext uri="{FF2B5EF4-FFF2-40B4-BE49-F238E27FC236}">
-                <a16:creationId xmlns:a16="http://schemas.microsoft.com/office/drawing/2014/main" id="{F5B5C5C8-4170-41F1-1E11-ED2C9C98FE7C}"/>
-              </a:ext>
-            </a:extLst>
-          </p:cNvPr>
+            <a:endParaRPr lang="en-US" dirty="0"/>
+          </a:p>
+        </p:txBody>
+      </p:sp>
+      <p:sp>
+        <p:nvSpPr>
+          <p:cNvPr id="5" name="Date Placeholder 4"/>
           <p:cNvSpPr>
             <a:spLocks noGrp="1"/>
           </p:cNvSpPr>
@@ -1423,13 +1249,7 @@
       </p:sp>
       <p:sp>
         <p:nvSpPr>
-          <p:cNvPr id="6" name="Footer Placeholder 5">
-            <a:extLst>
-              <a:ext uri="{FF2B5EF4-FFF2-40B4-BE49-F238E27FC236}">
-                <a16:creationId xmlns:a16="http://schemas.microsoft.com/office/drawing/2014/main" id="{6B31E449-7222-B42B-B512-270BD315A01B}"/>
-              </a:ext>
-            </a:extLst>
-          </p:cNvPr>
+          <p:cNvPr id="6" name="Footer Placeholder 5"/>
           <p:cNvSpPr>
             <a:spLocks noGrp="1"/>
           </p:cNvSpPr>
@@ -1448,13 +1268,7 @@
       </p:sp>
       <p:sp>
         <p:nvSpPr>
-          <p:cNvPr id="7" name="Slide Number Placeholder 6">
-            <a:extLst>
-              <a:ext uri="{FF2B5EF4-FFF2-40B4-BE49-F238E27FC236}">
-                <a16:creationId xmlns:a16="http://schemas.microsoft.com/office/drawing/2014/main" id="{86C92616-AE58-8D4B-5500-FA4EE8C8D85B}"/>
-              </a:ext>
-            </a:extLst>
-          </p:cNvPr>
+          <p:cNvPr id="7" name="Slide Number Placeholder 6"/>
           <p:cNvSpPr>
             <a:spLocks noGrp="1"/>
           </p:cNvSpPr>
@@ -1478,7 +1292,7 @@
     </p:spTree>
     <p:extLst>
       <p:ext uri="{BB962C8B-B14F-4D97-AF65-F5344CB8AC3E}">
-        <p14:creationId xmlns:p14="http://schemas.microsoft.com/office/powerpoint/2010/main" val="1920657799"/>
+        <p14:creationId xmlns:p14="http://schemas.microsoft.com/office/powerpoint/2010/main" val="3861996734"/>
       </p:ext>
     </p:extLst>
   </p:cSld>
@@ -1507,13 +1321,7 @@
       </p:grpSpPr>
       <p:sp>
         <p:nvSpPr>
-          <p:cNvPr id="2" name="Title 1">
-            <a:extLst>
-              <a:ext uri="{FF2B5EF4-FFF2-40B4-BE49-F238E27FC236}">
-                <a16:creationId xmlns:a16="http://schemas.microsoft.com/office/drawing/2014/main" id="{7FF61D34-2BE3-5CED-226E-5D07EA7FD0F2}"/>
-              </a:ext>
-            </a:extLst>
-          </p:cNvPr>
+          <p:cNvPr id="2" name="Title 1"/>
           <p:cNvSpPr>
             <a:spLocks noGrp="1"/>
           </p:cNvSpPr>
@@ -1523,8 +1331,8 @@
         </p:nvSpPr>
         <p:spPr>
           <a:xfrm>
-            <a:off x="839788" y="365125"/>
-            <a:ext cx="10515600" cy="1325563"/>
+            <a:off x="682328" y="365126"/>
+            <a:ext cx="8543925" cy="1325563"/>
           </a:xfrm>
         </p:spPr>
         <p:txBody>
@@ -1535,19 +1343,13 @@
               <a:rPr lang="en-US"/>
               <a:t>Click to edit Master title style</a:t>
             </a:r>
-            <a:endParaRPr lang="en-TH"/>
-          </a:p>
-        </p:txBody>
-      </p:sp>
-      <p:sp>
-        <p:nvSpPr>
-          <p:cNvPr id="3" name="Text Placeholder 2">
-            <a:extLst>
-              <a:ext uri="{FF2B5EF4-FFF2-40B4-BE49-F238E27FC236}">
-                <a16:creationId xmlns:a16="http://schemas.microsoft.com/office/drawing/2014/main" id="{499E74D2-C6C2-5A17-488C-538FF812E5E4}"/>
-              </a:ext>
-            </a:extLst>
-          </p:cNvPr>
+            <a:endParaRPr lang="en-US" dirty="0"/>
+          </a:p>
+        </p:txBody>
+      </p:sp>
+      <p:sp>
+        <p:nvSpPr>
+          <p:cNvPr id="3" name="Text Placeholder 2"/>
           <p:cNvSpPr>
             <a:spLocks noGrp="1"/>
           </p:cNvSpPr>
@@ -1557,8 +1359,8 @@
         </p:nvSpPr>
         <p:spPr>
           <a:xfrm>
-            <a:off x="839788" y="1681163"/>
-            <a:ext cx="5157787" cy="823912"/>
+            <a:off x="682329" y="1681163"/>
+            <a:ext cx="4190702" cy="823912"/>
           </a:xfrm>
         </p:spPr>
         <p:txBody>
@@ -1612,13 +1414,7 @@
       </p:sp>
       <p:sp>
         <p:nvSpPr>
-          <p:cNvPr id="4" name="Content Placeholder 3">
-            <a:extLst>
-              <a:ext uri="{FF2B5EF4-FFF2-40B4-BE49-F238E27FC236}">
-                <a16:creationId xmlns:a16="http://schemas.microsoft.com/office/drawing/2014/main" id="{4E619B88-DBC3-4796-E534-85CF81D30F33}"/>
-              </a:ext>
-            </a:extLst>
-          </p:cNvPr>
+          <p:cNvPr id="4" name="Content Placeholder 3"/>
           <p:cNvSpPr>
             <a:spLocks noGrp="1"/>
           </p:cNvSpPr>
@@ -1628,8 +1424,8 @@
         </p:nvSpPr>
         <p:spPr>
           <a:xfrm>
-            <a:off x="839788" y="2505075"/>
-            <a:ext cx="5157787" cy="3684588"/>
+            <a:off x="682329" y="2505075"/>
+            <a:ext cx="4190702" cy="3684588"/>
           </a:xfrm>
         </p:spPr>
         <p:txBody>
@@ -1669,19 +1465,13 @@
               <a:rPr lang="en-US"/>
               <a:t>Fifth level</a:t>
             </a:r>
-            <a:endParaRPr lang="en-TH"/>
-          </a:p>
-        </p:txBody>
-      </p:sp>
-      <p:sp>
-        <p:nvSpPr>
-          <p:cNvPr id="5" name="Text Placeholder 4">
-            <a:extLst>
-              <a:ext uri="{FF2B5EF4-FFF2-40B4-BE49-F238E27FC236}">
-                <a16:creationId xmlns:a16="http://schemas.microsoft.com/office/drawing/2014/main" id="{3B370A56-CA33-4396-2470-C48AB543ACA8}"/>
-              </a:ext>
-            </a:extLst>
-          </p:cNvPr>
+            <a:endParaRPr lang="en-US" dirty="0"/>
+          </a:p>
+        </p:txBody>
+      </p:sp>
+      <p:sp>
+        <p:nvSpPr>
+          <p:cNvPr id="5" name="Text Placeholder 4"/>
           <p:cNvSpPr>
             <a:spLocks noGrp="1"/>
           </p:cNvSpPr>
@@ -1691,8 +1481,8 @@
         </p:nvSpPr>
         <p:spPr>
           <a:xfrm>
-            <a:off x="6172200" y="1681163"/>
-            <a:ext cx="5183188" cy="823912"/>
+            <a:off x="5014913" y="1681163"/>
+            <a:ext cx="4211340" cy="823912"/>
           </a:xfrm>
         </p:spPr>
         <p:txBody>
@@ -1746,13 +1536,7 @@
       </p:sp>
       <p:sp>
         <p:nvSpPr>
-          <p:cNvPr id="6" name="Content Placeholder 5">
-            <a:extLst>
-              <a:ext uri="{FF2B5EF4-FFF2-40B4-BE49-F238E27FC236}">
-                <a16:creationId xmlns:a16="http://schemas.microsoft.com/office/drawing/2014/main" id="{7E8765EC-1C7C-4C8A-539B-B5CA964812C2}"/>
-              </a:ext>
-            </a:extLst>
-          </p:cNvPr>
+          <p:cNvPr id="6" name="Content Placeholder 5"/>
           <p:cNvSpPr>
             <a:spLocks noGrp="1"/>
           </p:cNvSpPr>
@@ -1762,8 +1546,8 @@
         </p:nvSpPr>
         <p:spPr>
           <a:xfrm>
-            <a:off x="6172200" y="2505075"/>
-            <a:ext cx="5183188" cy="3684588"/>
+            <a:off x="5014913" y="2505075"/>
+            <a:ext cx="4211340" cy="3684588"/>
           </a:xfrm>
         </p:spPr>
         <p:txBody>
@@ -1803,19 +1587,13 @@
               <a:rPr lang="en-US"/>
               <a:t>Fifth level</a:t>
             </a:r>
-            <a:endParaRPr lang="en-TH"/>
-          </a:p>
-        </p:txBody>
-      </p:sp>
-      <p:sp>
-        <p:nvSpPr>
-          <p:cNvPr id="7" name="Date Placeholder 6">
-            <a:extLst>
-              <a:ext uri="{FF2B5EF4-FFF2-40B4-BE49-F238E27FC236}">
-                <a16:creationId xmlns:a16="http://schemas.microsoft.com/office/drawing/2014/main" id="{31ADFBF0-6850-1976-1D76-3DCC312005A8}"/>
-              </a:ext>
-            </a:extLst>
-          </p:cNvPr>
+            <a:endParaRPr lang="en-US" dirty="0"/>
+          </a:p>
+        </p:txBody>
+      </p:sp>
+      <p:sp>
+        <p:nvSpPr>
+          <p:cNvPr id="7" name="Date Placeholder 6"/>
           <p:cNvSpPr>
             <a:spLocks noGrp="1"/>
           </p:cNvSpPr>
@@ -1838,13 +1616,7 @@
       </p:sp>
       <p:sp>
         <p:nvSpPr>
-          <p:cNvPr id="8" name="Footer Placeholder 7">
-            <a:extLst>
-              <a:ext uri="{FF2B5EF4-FFF2-40B4-BE49-F238E27FC236}">
-                <a16:creationId xmlns:a16="http://schemas.microsoft.com/office/drawing/2014/main" id="{BDBE4914-BD87-B010-8FDA-413BE7525C8C}"/>
-              </a:ext>
-            </a:extLst>
-          </p:cNvPr>
+          <p:cNvPr id="8" name="Footer Placeholder 7"/>
           <p:cNvSpPr>
             <a:spLocks noGrp="1"/>
           </p:cNvSpPr>
@@ -1863,13 +1635,7 @@
       </p:sp>
       <p:sp>
         <p:nvSpPr>
-          <p:cNvPr id="9" name="Slide Number Placeholder 8">
-            <a:extLst>
-              <a:ext uri="{FF2B5EF4-FFF2-40B4-BE49-F238E27FC236}">
-                <a16:creationId xmlns:a16="http://schemas.microsoft.com/office/drawing/2014/main" id="{24B03087-6E15-9E2B-B5CA-94240BF0D814}"/>
-              </a:ext>
-            </a:extLst>
-          </p:cNvPr>
+          <p:cNvPr id="9" name="Slide Number Placeholder 8"/>
           <p:cNvSpPr>
             <a:spLocks noGrp="1"/>
           </p:cNvSpPr>
@@ -1893,7 +1659,7 @@
     </p:spTree>
     <p:extLst>
       <p:ext uri="{BB962C8B-B14F-4D97-AF65-F5344CB8AC3E}">
-        <p14:creationId xmlns:p14="http://schemas.microsoft.com/office/powerpoint/2010/main" val="1668618319"/>
+        <p14:creationId xmlns:p14="http://schemas.microsoft.com/office/powerpoint/2010/main" val="1769747807"/>
       </p:ext>
     </p:extLst>
   </p:cSld>
@@ -1922,13 +1688,7 @@
       </p:grpSpPr>
       <p:sp>
         <p:nvSpPr>
-          <p:cNvPr id="2" name="Title 1">
-            <a:extLst>
-              <a:ext uri="{FF2B5EF4-FFF2-40B4-BE49-F238E27FC236}">
-                <a16:creationId xmlns:a16="http://schemas.microsoft.com/office/drawing/2014/main" id="{11793493-812E-2005-0762-B5550C96A2C3}"/>
-              </a:ext>
-            </a:extLst>
-          </p:cNvPr>
+          <p:cNvPr id="2" name="Title 1"/>
           <p:cNvSpPr>
             <a:spLocks noGrp="1"/>
           </p:cNvSpPr>
@@ -1945,19 +1705,13 @@
               <a:rPr lang="en-US"/>
               <a:t>Click to edit Master title style</a:t>
             </a:r>
-            <a:endParaRPr lang="en-TH"/>
-          </a:p>
-        </p:txBody>
-      </p:sp>
-      <p:sp>
-        <p:nvSpPr>
-          <p:cNvPr id="3" name="Date Placeholder 2">
-            <a:extLst>
-              <a:ext uri="{FF2B5EF4-FFF2-40B4-BE49-F238E27FC236}">
-                <a16:creationId xmlns:a16="http://schemas.microsoft.com/office/drawing/2014/main" id="{76106D83-45AF-97F7-EFB1-3A981431DDC9}"/>
-              </a:ext>
-            </a:extLst>
-          </p:cNvPr>
+            <a:endParaRPr lang="en-US" dirty="0"/>
+          </a:p>
+        </p:txBody>
+      </p:sp>
+      <p:sp>
+        <p:nvSpPr>
+          <p:cNvPr id="3" name="Date Placeholder 2"/>
           <p:cNvSpPr>
             <a:spLocks noGrp="1"/>
           </p:cNvSpPr>
@@ -1980,13 +1734,7 @@
       </p:sp>
       <p:sp>
         <p:nvSpPr>
-          <p:cNvPr id="4" name="Footer Placeholder 3">
-            <a:extLst>
-              <a:ext uri="{FF2B5EF4-FFF2-40B4-BE49-F238E27FC236}">
-                <a16:creationId xmlns:a16="http://schemas.microsoft.com/office/drawing/2014/main" id="{60FA7F47-CF76-4560-CE1E-40B3CBD577AF}"/>
-              </a:ext>
-            </a:extLst>
-          </p:cNvPr>
+          <p:cNvPr id="4" name="Footer Placeholder 3"/>
           <p:cNvSpPr>
             <a:spLocks noGrp="1"/>
           </p:cNvSpPr>
@@ -2005,13 +1753,7 @@
       </p:sp>
       <p:sp>
         <p:nvSpPr>
-          <p:cNvPr id="5" name="Slide Number Placeholder 4">
-            <a:extLst>
-              <a:ext uri="{FF2B5EF4-FFF2-40B4-BE49-F238E27FC236}">
-                <a16:creationId xmlns:a16="http://schemas.microsoft.com/office/drawing/2014/main" id="{9AB3C8EA-FD96-CDEA-ACB9-849C39A54E02}"/>
-              </a:ext>
-            </a:extLst>
-          </p:cNvPr>
+          <p:cNvPr id="5" name="Slide Number Placeholder 4"/>
           <p:cNvSpPr>
             <a:spLocks noGrp="1"/>
           </p:cNvSpPr>
@@ -2035,7 +1777,7 @@
     </p:spTree>
     <p:extLst>
       <p:ext uri="{BB962C8B-B14F-4D97-AF65-F5344CB8AC3E}">
-        <p14:creationId xmlns:p14="http://schemas.microsoft.com/office/powerpoint/2010/main" val="3240308743"/>
+        <p14:creationId xmlns:p14="http://schemas.microsoft.com/office/powerpoint/2010/main" val="1307068401"/>
       </p:ext>
     </p:extLst>
   </p:cSld>
@@ -2064,13 +1806,7 @@
       </p:grpSpPr>
       <p:sp>
         <p:nvSpPr>
-          <p:cNvPr id="2" name="Date Placeholder 1">
-            <a:extLst>
-              <a:ext uri="{FF2B5EF4-FFF2-40B4-BE49-F238E27FC236}">
-                <a16:creationId xmlns:a16="http://schemas.microsoft.com/office/drawing/2014/main" id="{699E20A6-EB49-151C-9C13-6A6D9BD41B56}"/>
-              </a:ext>
-            </a:extLst>
-          </p:cNvPr>
+          <p:cNvPr id="2" name="Date Placeholder 1"/>
           <p:cNvSpPr>
             <a:spLocks noGrp="1"/>
           </p:cNvSpPr>
@@ -2093,13 +1829,7 @@
       </p:sp>
       <p:sp>
         <p:nvSpPr>
-          <p:cNvPr id="3" name="Footer Placeholder 2">
-            <a:extLst>
-              <a:ext uri="{FF2B5EF4-FFF2-40B4-BE49-F238E27FC236}">
-                <a16:creationId xmlns:a16="http://schemas.microsoft.com/office/drawing/2014/main" id="{DD7E5495-916C-5B94-3F18-8D72CE3E399A}"/>
-              </a:ext>
-            </a:extLst>
-          </p:cNvPr>
+          <p:cNvPr id="3" name="Footer Placeholder 2"/>
           <p:cNvSpPr>
             <a:spLocks noGrp="1"/>
           </p:cNvSpPr>
@@ -2118,13 +1848,7 @@
       </p:sp>
       <p:sp>
         <p:nvSpPr>
-          <p:cNvPr id="4" name="Slide Number Placeholder 3">
-            <a:extLst>
-              <a:ext uri="{FF2B5EF4-FFF2-40B4-BE49-F238E27FC236}">
-                <a16:creationId xmlns:a16="http://schemas.microsoft.com/office/drawing/2014/main" id="{98230FE1-7B2D-A3E9-378B-D44DB435CC72}"/>
-              </a:ext>
-            </a:extLst>
-          </p:cNvPr>
+          <p:cNvPr id="4" name="Slide Number Placeholder 3"/>
           <p:cNvSpPr>
             <a:spLocks noGrp="1"/>
           </p:cNvSpPr>
@@ -2148,7 +1872,7 @@
     </p:spTree>
     <p:extLst>
       <p:ext uri="{BB962C8B-B14F-4D97-AF65-F5344CB8AC3E}">
-        <p14:creationId xmlns:p14="http://schemas.microsoft.com/office/powerpoint/2010/main" val="566956632"/>
+        <p14:creationId xmlns:p14="http://schemas.microsoft.com/office/powerpoint/2010/main" val="1035059177"/>
       </p:ext>
     </p:extLst>
   </p:cSld>
@@ -2177,13 +1901,7 @@
       </p:grpSpPr>
       <p:sp>
         <p:nvSpPr>
-          <p:cNvPr id="2" name="Title 1">
-            <a:extLst>
-              <a:ext uri="{FF2B5EF4-FFF2-40B4-BE49-F238E27FC236}">
-                <a16:creationId xmlns:a16="http://schemas.microsoft.com/office/drawing/2014/main" id="{C40AF882-EFFD-FDFD-4C35-1A6897B17D33}"/>
-              </a:ext>
-            </a:extLst>
-          </p:cNvPr>
+          <p:cNvPr id="2" name="Title 1"/>
           <p:cNvSpPr>
             <a:spLocks noGrp="1"/>
           </p:cNvSpPr>
@@ -2193,8 +1911,8 @@
         </p:nvSpPr>
         <p:spPr>
           <a:xfrm>
-            <a:off x="839788" y="457200"/>
-            <a:ext cx="3932237" cy="1600200"/>
+            <a:off x="682328" y="457200"/>
+            <a:ext cx="3194943" cy="1600200"/>
           </a:xfrm>
         </p:spPr>
         <p:txBody>
@@ -2209,19 +1927,13 @@
               <a:rPr lang="en-US"/>
               <a:t>Click to edit Master title style</a:t>
             </a:r>
-            <a:endParaRPr lang="en-TH"/>
-          </a:p>
-        </p:txBody>
-      </p:sp>
-      <p:sp>
-        <p:nvSpPr>
-          <p:cNvPr id="3" name="Content Placeholder 2">
-            <a:extLst>
-              <a:ext uri="{FF2B5EF4-FFF2-40B4-BE49-F238E27FC236}">
-                <a16:creationId xmlns:a16="http://schemas.microsoft.com/office/drawing/2014/main" id="{0DFBC943-0BE7-F556-94F1-A157007A4681}"/>
-              </a:ext>
-            </a:extLst>
-          </p:cNvPr>
+            <a:endParaRPr lang="en-US" dirty="0"/>
+          </a:p>
+        </p:txBody>
+      </p:sp>
+      <p:sp>
+        <p:nvSpPr>
+          <p:cNvPr id="3" name="Content Placeholder 2"/>
           <p:cNvSpPr>
             <a:spLocks noGrp="1"/>
           </p:cNvSpPr>
@@ -2231,8 +1943,8 @@
         </p:nvSpPr>
         <p:spPr>
           <a:xfrm>
-            <a:off x="5183188" y="987425"/>
-            <a:ext cx="6172200" cy="4873625"/>
+            <a:off x="4211340" y="987426"/>
+            <a:ext cx="5014913" cy="4873625"/>
           </a:xfrm>
         </p:spPr>
         <p:txBody>
@@ -2300,19 +2012,13 @@
               <a:rPr lang="en-US"/>
               <a:t>Fifth level</a:t>
             </a:r>
-            <a:endParaRPr lang="en-TH"/>
-          </a:p>
-        </p:txBody>
-      </p:sp>
-      <p:sp>
-        <p:nvSpPr>
-          <p:cNvPr id="4" name="Text Placeholder 3">
-            <a:extLst>
-              <a:ext uri="{FF2B5EF4-FFF2-40B4-BE49-F238E27FC236}">
-                <a16:creationId xmlns:a16="http://schemas.microsoft.com/office/drawing/2014/main" id="{9E96BD42-03DB-4022-7348-E3D42EA44EF4}"/>
-              </a:ext>
-            </a:extLst>
-          </p:cNvPr>
+            <a:endParaRPr lang="en-US" dirty="0"/>
+          </a:p>
+        </p:txBody>
+      </p:sp>
+      <p:sp>
+        <p:nvSpPr>
+          <p:cNvPr id="4" name="Text Placeholder 3"/>
           <p:cNvSpPr>
             <a:spLocks noGrp="1"/>
           </p:cNvSpPr>
@@ -2322,8 +2028,8 @@
         </p:nvSpPr>
         <p:spPr>
           <a:xfrm>
-            <a:off x="839788" y="2057400"/>
-            <a:ext cx="3932237" cy="3811588"/>
+            <a:off x="682328" y="2057400"/>
+            <a:ext cx="3194943" cy="3811588"/>
           </a:xfrm>
         </p:spPr>
         <p:txBody>
@@ -2377,13 +2083,7 @@
       </p:sp>
       <p:sp>
         <p:nvSpPr>
-          <p:cNvPr id="5" name="Date Placeholder 4">
-            <a:extLst>
-              <a:ext uri="{FF2B5EF4-FFF2-40B4-BE49-F238E27FC236}">
-                <a16:creationId xmlns:a16="http://schemas.microsoft.com/office/drawing/2014/main" id="{89387E87-7035-B37C-07CC-0E6A834FDE27}"/>
-              </a:ext>
-            </a:extLst>
-          </p:cNvPr>
+          <p:cNvPr id="5" name="Date Placeholder 4"/>
           <p:cNvSpPr>
             <a:spLocks noGrp="1"/>
           </p:cNvSpPr>
@@ -2406,13 +2106,7 @@
       </p:sp>
       <p:sp>
         <p:nvSpPr>
-          <p:cNvPr id="6" name="Footer Placeholder 5">
-            <a:extLst>
-              <a:ext uri="{FF2B5EF4-FFF2-40B4-BE49-F238E27FC236}">
-                <a16:creationId xmlns:a16="http://schemas.microsoft.com/office/drawing/2014/main" id="{B564001A-5772-9E8F-4F5F-DBC994858490}"/>
-              </a:ext>
-            </a:extLst>
-          </p:cNvPr>
+          <p:cNvPr id="6" name="Footer Placeholder 5"/>
           <p:cNvSpPr>
             <a:spLocks noGrp="1"/>
           </p:cNvSpPr>
@@ -2431,13 +2125,7 @@
       </p:sp>
       <p:sp>
         <p:nvSpPr>
-          <p:cNvPr id="7" name="Slide Number Placeholder 6">
-            <a:extLst>
-              <a:ext uri="{FF2B5EF4-FFF2-40B4-BE49-F238E27FC236}">
-                <a16:creationId xmlns:a16="http://schemas.microsoft.com/office/drawing/2014/main" id="{15DFF77E-73D8-E01D-AC4B-A0BDC301D375}"/>
-              </a:ext>
-            </a:extLst>
-          </p:cNvPr>
+          <p:cNvPr id="7" name="Slide Number Placeholder 6"/>
           <p:cNvSpPr>
             <a:spLocks noGrp="1"/>
           </p:cNvSpPr>
@@ -2461,7 +2149,7 @@
     </p:spTree>
     <p:extLst>
       <p:ext uri="{BB962C8B-B14F-4D97-AF65-F5344CB8AC3E}">
-        <p14:creationId xmlns:p14="http://schemas.microsoft.com/office/powerpoint/2010/main" val="755238725"/>
+        <p14:creationId xmlns:p14="http://schemas.microsoft.com/office/powerpoint/2010/main" val="2570618696"/>
       </p:ext>
     </p:extLst>
   </p:cSld>
@@ -2490,13 +2178,7 @@
       </p:grpSpPr>
       <p:sp>
         <p:nvSpPr>
-          <p:cNvPr id="2" name="Title 1">
-            <a:extLst>
-              <a:ext uri="{FF2B5EF4-FFF2-40B4-BE49-F238E27FC236}">
-                <a16:creationId xmlns:a16="http://schemas.microsoft.com/office/drawing/2014/main" id="{7985BB72-0CD7-AE41-EBF1-34725A037A1D}"/>
-              </a:ext>
-            </a:extLst>
-          </p:cNvPr>
+          <p:cNvPr id="2" name="Title 1"/>
           <p:cNvSpPr>
             <a:spLocks noGrp="1"/>
           </p:cNvSpPr>
@@ -2506,8 +2188,8 @@
         </p:nvSpPr>
         <p:spPr>
           <a:xfrm>
-            <a:off x="839788" y="457200"/>
-            <a:ext cx="3932237" cy="1600200"/>
+            <a:off x="682328" y="457200"/>
+            <a:ext cx="3194943" cy="1600200"/>
           </a:xfrm>
         </p:spPr>
         <p:txBody>
@@ -2522,21 +2204,15 @@
               <a:rPr lang="en-US"/>
               <a:t>Click to edit Master title style</a:t>
             </a:r>
-            <a:endParaRPr lang="en-TH"/>
-          </a:p>
-        </p:txBody>
-      </p:sp>
-      <p:sp>
-        <p:nvSpPr>
-          <p:cNvPr id="3" name="Picture Placeholder 2">
-            <a:extLst>
-              <a:ext uri="{FF2B5EF4-FFF2-40B4-BE49-F238E27FC236}">
-                <a16:creationId xmlns:a16="http://schemas.microsoft.com/office/drawing/2014/main" id="{10F0B045-21F0-57A3-1EAD-8160F432DD58}"/>
-              </a:ext>
-            </a:extLst>
-          </p:cNvPr>
-          <p:cNvSpPr>
-            <a:spLocks noGrp="1"/>
+            <a:endParaRPr lang="en-US" dirty="0"/>
+          </a:p>
+        </p:txBody>
+      </p:sp>
+      <p:sp>
+        <p:nvSpPr>
+          <p:cNvPr id="3" name="Picture Placeholder 2"/>
+          <p:cNvSpPr>
+            <a:spLocks noGrp="1" noChangeAspect="1"/>
           </p:cNvSpPr>
           <p:nvPr>
             <p:ph type="pic" idx="1"/>
@@ -2544,12 +2220,12 @@
         </p:nvSpPr>
         <p:spPr>
           <a:xfrm>
-            <a:off x="5183188" y="987425"/>
-            <a:ext cx="6172200" cy="4873625"/>
+            <a:off x="4211340" y="987426"/>
+            <a:ext cx="5014913" cy="4873625"/>
           </a:xfrm>
         </p:spPr>
         <p:txBody>
-          <a:bodyPr/>
+          <a:bodyPr anchor="t"/>
           <a:lstStyle>
             <a:lvl1pPr marL="0" indent="0">
               <a:buNone/>
@@ -2589,19 +2265,17 @@
             </a:lvl9pPr>
           </a:lstStyle>
           <a:p>
-            <a:endParaRPr lang="en-TH"/>
-          </a:p>
-        </p:txBody>
-      </p:sp>
-      <p:sp>
-        <p:nvSpPr>
-          <p:cNvPr id="4" name="Text Placeholder 3">
-            <a:extLst>
-              <a:ext uri="{FF2B5EF4-FFF2-40B4-BE49-F238E27FC236}">
-                <a16:creationId xmlns:a16="http://schemas.microsoft.com/office/drawing/2014/main" id="{1C7257C6-F328-98D5-DCE7-AE8D8241BD72}"/>
-              </a:ext>
-            </a:extLst>
-          </p:cNvPr>
+            <a:r>
+              <a:rPr lang="en-US"/>
+              <a:t>Click icon to add picture</a:t>
+            </a:r>
+            <a:endParaRPr lang="en-US" dirty="0"/>
+          </a:p>
+        </p:txBody>
+      </p:sp>
+      <p:sp>
+        <p:nvSpPr>
+          <p:cNvPr id="4" name="Text Placeholder 3"/>
           <p:cNvSpPr>
             <a:spLocks noGrp="1"/>
           </p:cNvSpPr>
@@ -2611,8 +2285,8 @@
         </p:nvSpPr>
         <p:spPr>
           <a:xfrm>
-            <a:off x="839788" y="2057400"/>
-            <a:ext cx="3932237" cy="3811588"/>
+            <a:off x="682328" y="2057400"/>
+            <a:ext cx="3194943" cy="3811588"/>
           </a:xfrm>
         </p:spPr>
         <p:txBody>
@@ -2666,13 +2340,7 @@
       </p:sp>
       <p:sp>
         <p:nvSpPr>
-          <p:cNvPr id="5" name="Date Placeholder 4">
-            <a:extLst>
-              <a:ext uri="{FF2B5EF4-FFF2-40B4-BE49-F238E27FC236}">
-                <a16:creationId xmlns:a16="http://schemas.microsoft.com/office/drawing/2014/main" id="{CC5BA008-9235-BA6D-E21A-F3A957A99380}"/>
-              </a:ext>
-            </a:extLst>
-          </p:cNvPr>
+          <p:cNvPr id="5" name="Date Placeholder 4"/>
           <p:cNvSpPr>
             <a:spLocks noGrp="1"/>
           </p:cNvSpPr>
@@ -2695,13 +2363,7 @@
       </p:sp>
       <p:sp>
         <p:nvSpPr>
-          <p:cNvPr id="6" name="Footer Placeholder 5">
-            <a:extLst>
-              <a:ext uri="{FF2B5EF4-FFF2-40B4-BE49-F238E27FC236}">
-                <a16:creationId xmlns:a16="http://schemas.microsoft.com/office/drawing/2014/main" id="{CD11713B-DA80-CCC4-2558-08ED549CD907}"/>
-              </a:ext>
-            </a:extLst>
-          </p:cNvPr>
+          <p:cNvPr id="6" name="Footer Placeholder 5"/>
           <p:cNvSpPr>
             <a:spLocks noGrp="1"/>
           </p:cNvSpPr>
@@ -2720,13 +2382,7 @@
       </p:sp>
       <p:sp>
         <p:nvSpPr>
-          <p:cNvPr id="7" name="Slide Number Placeholder 6">
-            <a:extLst>
-              <a:ext uri="{FF2B5EF4-FFF2-40B4-BE49-F238E27FC236}">
-                <a16:creationId xmlns:a16="http://schemas.microsoft.com/office/drawing/2014/main" id="{3E54D6C3-5D30-6081-0F74-0E0E604990AE}"/>
-              </a:ext>
-            </a:extLst>
-          </p:cNvPr>
+          <p:cNvPr id="7" name="Slide Number Placeholder 6"/>
           <p:cNvSpPr>
             <a:spLocks noGrp="1"/>
           </p:cNvSpPr>
@@ -2750,7 +2406,7 @@
     </p:spTree>
     <p:extLst>
       <p:ext uri="{BB962C8B-B14F-4D97-AF65-F5344CB8AC3E}">
-        <p14:creationId xmlns:p14="http://schemas.microsoft.com/office/powerpoint/2010/main" val="3893061976"/>
+        <p14:creationId xmlns:p14="http://schemas.microsoft.com/office/powerpoint/2010/main" val="2447110540"/>
       </p:ext>
     </p:extLst>
   </p:cSld>
@@ -2784,13 +2440,7 @@
       </p:grpSpPr>
       <p:sp>
         <p:nvSpPr>
-          <p:cNvPr id="2" name="Title Placeholder 1">
-            <a:extLst>
-              <a:ext uri="{FF2B5EF4-FFF2-40B4-BE49-F238E27FC236}">
-                <a16:creationId xmlns:a16="http://schemas.microsoft.com/office/drawing/2014/main" id="{13592130-254E-6507-04D1-0A3F6A21CA43}"/>
-              </a:ext>
-            </a:extLst>
-          </p:cNvPr>
+          <p:cNvPr id="2" name="Title Placeholder 1"/>
           <p:cNvSpPr>
             <a:spLocks noGrp="1"/>
           </p:cNvSpPr>
@@ -2800,8 +2450,8 @@
         </p:nvSpPr>
         <p:spPr>
           <a:xfrm>
-            <a:off x="838200" y="365125"/>
-            <a:ext cx="10515600" cy="1325563"/>
+            <a:off x="681038" y="365126"/>
+            <a:ext cx="8543925" cy="1325563"/>
           </a:xfrm>
           <a:prstGeom prst="rect">
             <a:avLst/>
@@ -2817,19 +2467,13 @@
               <a:rPr lang="en-US"/>
               <a:t>Click to edit Master title style</a:t>
             </a:r>
-            <a:endParaRPr lang="en-TH"/>
-          </a:p>
-        </p:txBody>
-      </p:sp>
-      <p:sp>
-        <p:nvSpPr>
-          <p:cNvPr id="3" name="Text Placeholder 2">
-            <a:extLst>
-              <a:ext uri="{FF2B5EF4-FFF2-40B4-BE49-F238E27FC236}">
-                <a16:creationId xmlns:a16="http://schemas.microsoft.com/office/drawing/2014/main" id="{60BE1644-E114-CFC6-0C36-710EFF9BFD0B}"/>
-              </a:ext>
-            </a:extLst>
-          </p:cNvPr>
+            <a:endParaRPr lang="en-US" dirty="0"/>
+          </a:p>
+        </p:txBody>
+      </p:sp>
+      <p:sp>
+        <p:nvSpPr>
+          <p:cNvPr id="3" name="Text Placeholder 2"/>
           <p:cNvSpPr>
             <a:spLocks noGrp="1"/>
           </p:cNvSpPr>
@@ -2839,8 +2483,8 @@
         </p:nvSpPr>
         <p:spPr>
           <a:xfrm>
-            <a:off x="838200" y="1825625"/>
-            <a:ext cx="10515600" cy="4351338"/>
+            <a:off x="681038" y="1825625"/>
+            <a:ext cx="8543925" cy="4351338"/>
           </a:xfrm>
           <a:prstGeom prst="rect">
             <a:avLst/>
@@ -2885,19 +2529,13 @@
               <a:rPr lang="en-US"/>
               <a:t>Fifth level</a:t>
             </a:r>
-            <a:endParaRPr lang="en-TH"/>
-          </a:p>
-        </p:txBody>
-      </p:sp>
-      <p:sp>
-        <p:nvSpPr>
-          <p:cNvPr id="4" name="Date Placeholder 3">
-            <a:extLst>
-              <a:ext uri="{FF2B5EF4-FFF2-40B4-BE49-F238E27FC236}">
-                <a16:creationId xmlns:a16="http://schemas.microsoft.com/office/drawing/2014/main" id="{DE7A7C61-27A7-E010-5CED-7A276410A56D}"/>
-              </a:ext>
-            </a:extLst>
-          </p:cNvPr>
+            <a:endParaRPr lang="en-US" dirty="0"/>
+          </a:p>
+        </p:txBody>
+      </p:sp>
+      <p:sp>
+        <p:nvSpPr>
+          <p:cNvPr id="4" name="Date Placeholder 3"/>
           <p:cNvSpPr>
             <a:spLocks noGrp="1"/>
           </p:cNvSpPr>
@@ -2907,8 +2545,8 @@
         </p:nvSpPr>
         <p:spPr>
           <a:xfrm>
-            <a:off x="838200" y="6356350"/>
-            <a:ext cx="2743200" cy="365125"/>
+            <a:off x="681038" y="6356352"/>
+            <a:ext cx="2228850" cy="365125"/>
           </a:xfrm>
           <a:prstGeom prst="rect">
             <a:avLst/>
@@ -2938,13 +2576,7 @@
       </p:sp>
       <p:sp>
         <p:nvSpPr>
-          <p:cNvPr id="5" name="Footer Placeholder 4">
-            <a:extLst>
-              <a:ext uri="{FF2B5EF4-FFF2-40B4-BE49-F238E27FC236}">
-                <a16:creationId xmlns:a16="http://schemas.microsoft.com/office/drawing/2014/main" id="{A5B7B5E7-499C-C16E-328B-42246544A9C8}"/>
-              </a:ext>
-            </a:extLst>
-          </p:cNvPr>
+          <p:cNvPr id="5" name="Footer Placeholder 4"/>
           <p:cNvSpPr>
             <a:spLocks noGrp="1"/>
           </p:cNvSpPr>
@@ -2954,8 +2586,8 @@
         </p:nvSpPr>
         <p:spPr>
           <a:xfrm>
-            <a:off x="4038600" y="6356350"/>
-            <a:ext cx="4114800" cy="365125"/>
+            <a:off x="3281363" y="6356352"/>
+            <a:ext cx="3343275" cy="365125"/>
           </a:xfrm>
           <a:prstGeom prst="rect">
             <a:avLst/>
@@ -2981,13 +2613,7 @@
       </p:sp>
       <p:sp>
         <p:nvSpPr>
-          <p:cNvPr id="6" name="Slide Number Placeholder 5">
-            <a:extLst>
-              <a:ext uri="{FF2B5EF4-FFF2-40B4-BE49-F238E27FC236}">
-                <a16:creationId xmlns:a16="http://schemas.microsoft.com/office/drawing/2014/main" id="{912E14CB-0D8F-C707-1B11-6158B7805C5B}"/>
-              </a:ext>
-            </a:extLst>
-          </p:cNvPr>
+          <p:cNvPr id="6" name="Slide Number Placeholder 5"/>
           <p:cNvSpPr>
             <a:spLocks noGrp="1"/>
           </p:cNvSpPr>
@@ -2997,8 +2623,8 @@
         </p:nvSpPr>
         <p:spPr>
           <a:xfrm>
-            <a:off x="8610600" y="6356350"/>
-            <a:ext cx="2743200" cy="365125"/>
+            <a:off x="6996113" y="6356352"/>
+            <a:ext cx="2228850" cy="365125"/>
           </a:xfrm>
           <a:prstGeom prst="rect">
             <a:avLst/>
@@ -3029,23 +2655,23 @@
     </p:spTree>
     <p:extLst>
       <p:ext uri="{BB962C8B-B14F-4D97-AF65-F5344CB8AC3E}">
-        <p14:creationId xmlns:p14="http://schemas.microsoft.com/office/powerpoint/2010/main" val="3402709786"/>
+        <p14:creationId xmlns:p14="http://schemas.microsoft.com/office/powerpoint/2010/main" val="3919872874"/>
       </p:ext>
     </p:extLst>
   </p:cSld>
   <p:clrMap bg1="lt1" tx1="dk1" bg2="lt2" tx2="dk2" accent1="accent1" accent2="accent2" accent3="accent3" accent4="accent4" accent5="accent5" accent6="accent6" hlink="hlink" folHlink="folHlink"/>
   <p:sldLayoutIdLst>
-    <p:sldLayoutId id="2147483649" r:id="rId1"/>
-    <p:sldLayoutId id="2147483650" r:id="rId2"/>
-    <p:sldLayoutId id="2147483651" r:id="rId3"/>
-    <p:sldLayoutId id="2147483652" r:id="rId4"/>
-    <p:sldLayoutId id="2147483653" r:id="rId5"/>
-    <p:sldLayoutId id="2147483654" r:id="rId6"/>
-    <p:sldLayoutId id="2147483655" r:id="rId7"/>
-    <p:sldLayoutId id="2147483656" r:id="rId8"/>
-    <p:sldLayoutId id="2147483657" r:id="rId9"/>
-    <p:sldLayoutId id="2147483658" r:id="rId10"/>
-    <p:sldLayoutId id="2147483659" r:id="rId11"/>
+    <p:sldLayoutId id="2147483661" r:id="rId1"/>
+    <p:sldLayoutId id="2147483662" r:id="rId2"/>
+    <p:sldLayoutId id="2147483663" r:id="rId3"/>
+    <p:sldLayoutId id="2147483664" r:id="rId4"/>
+    <p:sldLayoutId id="2147483665" r:id="rId5"/>
+    <p:sldLayoutId id="2147483666" r:id="rId6"/>
+    <p:sldLayoutId id="2147483667" r:id="rId7"/>
+    <p:sldLayoutId id="2147483668" r:id="rId8"/>
+    <p:sldLayoutId id="2147483669" r:id="rId9"/>
+    <p:sldLayoutId id="2147483670" r:id="rId10"/>
+    <p:sldLayoutId id="2147483671" r:id="rId11"/>
   </p:sldLayoutIdLst>
   <p:txStyles>
     <p:titleStyle>
@@ -3233,7 +2859,7 @@
     </p:bodyStyle>
     <p:otherStyle>
       <a:defPPr>
-        <a:defRPr lang="en-TH"/>
+        <a:defRPr lang="en-US"/>
       </a:defPPr>
       <a:lvl1pPr marL="0" algn="l" defTabSz="914400" rtl="0" eaLnBrk="1" latinLnBrk="0" hangingPunct="1">
         <a:defRPr sz="1800" kern="1200">
@@ -3369,8 +2995,8 @@
         </p:nvSpPr>
         <p:spPr bwMode="auto">
           <a:xfrm>
-            <a:off x="491317" y="958426"/>
-            <a:ext cx="6360420" cy="3231654"/>
+            <a:off x="168964" y="1111201"/>
+            <a:ext cx="2286000" cy="1367683"/>
           </a:xfrm>
           <a:prstGeom prst="rect">
             <a:avLst/>
@@ -3384,7 +3010,7 @@
           <a:effectLst/>
         </p:spPr>
         <p:txBody>
-          <a:bodyPr vert="horz" wrap="square" lIns="91440" tIns="45720" rIns="91440" bIns="45720" numCol="1" anchor="ctr" anchorCtr="0" compatLnSpc="1">
+          <a:bodyPr vert="horz" wrap="square" lIns="74295" tIns="37148" rIns="74295" bIns="37148" numCol="1" anchor="ctr" anchorCtr="0" compatLnSpc="1">
             <a:prstTxWarp prst="textNoShape">
               <a:avLst/>
             </a:prstTxWarp>
@@ -3520,1119 +3146,407 @@
           </a:lstStyle>
           <a:p>
             <a:r>
-              <a:rPr lang="en-TH" sz="1200" b="1" dirty="0">
+              <a:rPr lang="en-US" sz="600" b="1" dirty="0">
                 <a:solidFill>
                   <a:srgbClr val="FF0000"/>
                 </a:solidFill>
                 <a:latin typeface="Roboto Mono" pitchFamily="49" charset="0"/>
                 <a:ea typeface="Roboto Mono" pitchFamily="49" charset="0"/>
               </a:rPr>
-              <a:t>#!InfiniteList.java</a:t>
-            </a:r>
-            <a:endParaRPr kumimoji="0" lang="en-TH" altLang="en-TH" sz="1200" i="0" u="none" strike="noStrike" cap="none" normalizeH="0" baseline="0" dirty="0">
-              <a:ln>
-                <a:noFill/>
-              </a:ln>
-              <a:effectLst/>
-              <a:latin typeface="Roboto Mono" pitchFamily="49" charset="0"/>
-              <a:ea typeface="Roboto Mono" pitchFamily="49" charset="0"/>
-            </a:endParaRPr>
-          </a:p>
-          <a:p>
-            <a:r>
-              <a:rPr kumimoji="0" lang="en-TH" altLang="en-TH" sz="1200" i="0" u="none" strike="noStrike" cap="none" normalizeH="0" baseline="0" dirty="0">
-                <a:ln>
-                  <a:noFill/>
-                </a:ln>
-                <a:effectLst/>
-                <a:latin typeface="Roboto Mono" pitchFamily="49" charset="0"/>
-                <a:ea typeface="Roboto Mono" pitchFamily="49" charset="0"/>
-              </a:rPr>
-              <a:t>class </a:t>
-            </a:r>
-            <a:r>
-              <a:rPr kumimoji="0" lang="en-TH" altLang="en-TH" sz="1200" b="1" i="0" u="none" strike="noStrike" cap="none" normalizeH="0" baseline="0" dirty="0">
-                <a:ln>
-                  <a:noFill/>
-                </a:ln>
-                <a:effectLst/>
-                <a:latin typeface="Roboto Mono" pitchFamily="49" charset="0"/>
-                <a:ea typeface="Roboto Mono" pitchFamily="49" charset="0"/>
-              </a:rPr>
-              <a:t>InfiniteList</a:t>
-            </a:r>
-            <a:r>
-              <a:rPr kumimoji="0" lang="en-TH" altLang="en-TH" sz="1200" i="0" u="none" strike="noStrike" cap="none" normalizeH="0" baseline="0" dirty="0">
-                <a:ln>
-                  <a:noFill/>
-                </a:ln>
-                <a:effectLst/>
-                <a:latin typeface="Roboto Mono" pitchFamily="49" charset="0"/>
-                <a:ea typeface="Roboto Mono" pitchFamily="49" charset="0"/>
-              </a:rPr>
-              <a:t>&lt;T&gt; {</a:t>
-            </a:r>
-          </a:p>
-          <a:p>
-            <a:pPr lvl="1"/>
-            <a:endParaRPr lang="en-TH" altLang="en-TH" sz="1200" dirty="0">
-              <a:latin typeface="Roboto Mono" pitchFamily="49" charset="0"/>
-              <a:ea typeface="Roboto Mono" pitchFamily="49" charset="0"/>
-            </a:endParaRPr>
-          </a:p>
-          <a:p>
-            <a:pPr lvl="1"/>
-            <a:r>
-              <a:rPr lang="en-US" altLang="en-TH" sz="1200" dirty="0">
-                <a:latin typeface="Roboto Mono" pitchFamily="49" charset="0"/>
-                <a:ea typeface="Roboto Mono" pitchFamily="49" charset="0"/>
-              </a:rPr>
-              <a:t>public </a:t>
-            </a:r>
-            <a:r>
-              <a:rPr lang="en-US" altLang="en-TH" sz="1200" dirty="0" err="1">
-                <a:latin typeface="Roboto Mono" pitchFamily="49" charset="0"/>
-                <a:ea typeface="Roboto Mono" pitchFamily="49" charset="0"/>
-              </a:rPr>
-              <a:t>boolean</a:t>
-            </a:r>
-            <a:r>
-              <a:rPr lang="en-US" altLang="en-TH" sz="1200" dirty="0">
-                <a:latin typeface="Roboto Mono" pitchFamily="49" charset="0"/>
-                <a:ea typeface="Roboto Mono" pitchFamily="49" charset="0"/>
-              </a:rPr>
-              <a:t> </a:t>
-            </a:r>
-            <a:r>
-              <a:rPr lang="en-US" altLang="en-TH" sz="1200" dirty="0" err="1">
-                <a:latin typeface="Roboto Mono" pitchFamily="49" charset="0"/>
-                <a:ea typeface="Roboto Mono" pitchFamily="49" charset="0"/>
-              </a:rPr>
-              <a:t>isSentinel</a:t>
-            </a:r>
-            <a:r>
-              <a:rPr lang="en-US" altLang="en-TH" sz="1200" dirty="0">
-                <a:latin typeface="Roboto Mono" pitchFamily="49" charset="0"/>
-                <a:ea typeface="Roboto Mono" pitchFamily="49" charset="0"/>
-              </a:rPr>
-              <a:t>() {</a:t>
-            </a:r>
-          </a:p>
-          <a:p>
-            <a:pPr lvl="2"/>
-            <a:r>
-              <a:rPr lang="en-US" altLang="en-TH" sz="1200" dirty="0">
-                <a:latin typeface="Roboto Mono" pitchFamily="49" charset="0"/>
-                <a:ea typeface="Roboto Mono" pitchFamily="49" charset="0"/>
-              </a:rPr>
-              <a:t>return false;</a:t>
-            </a:r>
-          </a:p>
-          <a:p>
-            <a:pPr lvl="1"/>
-            <a:r>
-              <a:rPr lang="en-US" altLang="en-TH" sz="1200" dirty="0">
-                <a:latin typeface="Roboto Mono" pitchFamily="49" charset="0"/>
-                <a:ea typeface="Roboto Mono" pitchFamily="49" charset="0"/>
-              </a:rPr>
-              <a:t>}</a:t>
-            </a:r>
-          </a:p>
-          <a:p>
-            <a:pPr lvl="1"/>
-            <a:endParaRPr kumimoji="0" lang="en-US" altLang="en-TH" sz="1200" i="0" u="none" strike="noStrike" cap="none" normalizeH="0" baseline="0" dirty="0">
-              <a:ln>
-                <a:noFill/>
-              </a:ln>
-              <a:effectLst/>
-              <a:latin typeface="Roboto Mono" pitchFamily="49" charset="0"/>
-              <a:ea typeface="Roboto Mono" pitchFamily="49" charset="0"/>
-            </a:endParaRPr>
-          </a:p>
-          <a:p>
-            <a:pPr lvl="1"/>
-            <a:r>
-              <a:rPr lang="en-US" altLang="en-TH" sz="1200" dirty="0">
-                <a:latin typeface="Roboto Mono" pitchFamily="49" charset="0"/>
-                <a:ea typeface="Roboto Mono" pitchFamily="49" charset="0"/>
-              </a:rPr>
-              <a:t>public static &lt;T&gt; InfiniteList&lt;T&gt; </a:t>
-            </a:r>
-            <a:r>
-              <a:rPr lang="en-US" altLang="en-TH" sz="1200" b="1" dirty="0">
-                <a:solidFill>
-                  <a:srgbClr val="C00000"/>
-                </a:solidFill>
-                <a:latin typeface="Roboto Mono" pitchFamily="49" charset="0"/>
-                <a:ea typeface="Roboto Mono" pitchFamily="49" charset="0"/>
-              </a:rPr>
-              <a:t>sentinel</a:t>
-            </a:r>
-            <a:r>
-              <a:rPr lang="en-US" altLang="en-TH" sz="1200" dirty="0">
-                <a:latin typeface="Roboto Mono" pitchFamily="49" charset="0"/>
-                <a:ea typeface="Roboto Mono" pitchFamily="49" charset="0"/>
-              </a:rPr>
-              <a:t>() {</a:t>
-            </a:r>
-          </a:p>
-          <a:p>
-            <a:pPr lvl="2"/>
-            <a:r>
-              <a:rPr lang="en-US" altLang="en-TH" sz="1200" dirty="0">
-                <a:latin typeface="Roboto Mono" pitchFamily="49" charset="0"/>
-                <a:ea typeface="Roboto Mono" pitchFamily="49" charset="0"/>
-              </a:rPr>
-              <a:t>@</a:t>
-            </a:r>
-            <a:r>
-              <a:rPr lang="en-US" altLang="en-TH" sz="1200" dirty="0" err="1">
-                <a:latin typeface="Roboto Mono" pitchFamily="49" charset="0"/>
-                <a:ea typeface="Roboto Mono" pitchFamily="49" charset="0"/>
-              </a:rPr>
-              <a:t>SuppressWarnings</a:t>
-            </a:r>
-            <a:r>
-              <a:rPr lang="en-US" altLang="en-TH" sz="1200" dirty="0">
-                <a:latin typeface="Roboto Mono" pitchFamily="49" charset="0"/>
-                <a:ea typeface="Roboto Mono" pitchFamily="49" charset="0"/>
-              </a:rPr>
-              <a:t>("unchecked")</a:t>
-            </a:r>
-          </a:p>
-          <a:p>
-            <a:pPr lvl="1"/>
-            <a:r>
-              <a:rPr lang="en-US" altLang="en-TH" sz="1200" dirty="0">
-                <a:latin typeface="Roboto Mono" pitchFamily="49" charset="0"/>
-                <a:ea typeface="Roboto Mono" pitchFamily="49" charset="0"/>
-              </a:rPr>
-              <a:t>     InfiniteList&lt;T&gt; a = (InfiniteList&lt;T&gt;) </a:t>
-            </a:r>
-            <a:r>
-              <a:rPr lang="en-US" altLang="en-TH" sz="1200" b="1" dirty="0">
-                <a:latin typeface="Roboto Mono" pitchFamily="49" charset="0"/>
-                <a:ea typeface="Roboto Mono" pitchFamily="49" charset="0"/>
-              </a:rPr>
-              <a:t>SENTINEL</a:t>
-            </a:r>
-            <a:r>
-              <a:rPr lang="en-US" altLang="en-TH" sz="1200" dirty="0">
-                <a:latin typeface="Roboto Mono" pitchFamily="49" charset="0"/>
-                <a:ea typeface="Roboto Mono" pitchFamily="49" charset="0"/>
-              </a:rPr>
-              <a:t>;</a:t>
-            </a:r>
-          </a:p>
-          <a:p>
-            <a:pPr lvl="1"/>
-            <a:r>
-              <a:rPr lang="en-US" altLang="en-TH" sz="1200" dirty="0">
-                <a:latin typeface="Roboto Mono" pitchFamily="49" charset="0"/>
-                <a:ea typeface="Roboto Mono" pitchFamily="49" charset="0"/>
-              </a:rPr>
-              <a:t>     return a;</a:t>
-            </a:r>
-          </a:p>
-          <a:p>
-            <a:pPr lvl="1"/>
-            <a:r>
-              <a:rPr lang="en-US" altLang="en-TH" sz="1200" dirty="0">
-                <a:latin typeface="Roboto Mono" pitchFamily="49" charset="0"/>
-                <a:ea typeface="Roboto Mono" pitchFamily="49" charset="0"/>
-              </a:rPr>
-              <a:t>} </a:t>
-            </a:r>
-          </a:p>
-          <a:p>
-            <a:pPr lvl="1"/>
-            <a:endParaRPr lang="en-US" altLang="en-TH" sz="1200" b="1" dirty="0">
-              <a:solidFill>
-                <a:schemeClr val="tx2">
-                  <a:lumMod val="75000"/>
-                </a:schemeClr>
-              </a:solidFill>
-              <a:latin typeface="Roboto Mono" pitchFamily="49" charset="0"/>
-              <a:ea typeface="Roboto Mono" pitchFamily="49" charset="0"/>
-            </a:endParaRPr>
-          </a:p>
-          <a:p>
-            <a:pPr lvl="1"/>
-            <a:r>
-              <a:rPr lang="en-US" altLang="en-TH" sz="1200" b="1" dirty="0">
-                <a:solidFill>
-                  <a:schemeClr val="tx2">
-                    <a:lumMod val="75000"/>
-                  </a:schemeClr>
-                </a:solidFill>
-                <a:latin typeface="Roboto Mono" pitchFamily="49" charset="0"/>
-                <a:ea typeface="Roboto Mono" pitchFamily="49" charset="0"/>
-              </a:rPr>
-              <a:t>private static final Sentinel SENTINEL = new Sentinel();</a:t>
-            </a:r>
-            <a:endParaRPr lang="en-TH" altLang="en-TH" sz="1200" b="1" dirty="0">
-              <a:solidFill>
-                <a:schemeClr val="tx2">
-                  <a:lumMod val="75000"/>
-                </a:schemeClr>
-              </a:solidFill>
-              <a:latin typeface="Roboto Mono" pitchFamily="49" charset="0"/>
-              <a:ea typeface="Roboto Mono" pitchFamily="49" charset="0"/>
-            </a:endParaRPr>
-          </a:p>
-          <a:p>
-            <a:endParaRPr kumimoji="0" lang="en-TH" altLang="en-TH" sz="1200" i="0" u="none" strike="noStrike" cap="none" normalizeH="0" baseline="0" dirty="0">
-              <a:ln>
-                <a:noFill/>
-              </a:ln>
-              <a:effectLst/>
-              <a:latin typeface="Roboto Mono" pitchFamily="49" charset="0"/>
-              <a:ea typeface="Roboto Mono" pitchFamily="49" charset="0"/>
-            </a:endParaRPr>
-          </a:p>
-          <a:p>
-            <a:r>
-              <a:rPr kumimoji="0" lang="en-TH" altLang="en-TH" sz="1200" i="0" u="none" strike="noStrike" cap="none" normalizeH="0" baseline="0" dirty="0">
-                <a:ln>
-                  <a:noFill/>
-                </a:ln>
-                <a:effectLst/>
-                <a:latin typeface="Roboto Mono" pitchFamily="49" charset="0"/>
-                <a:ea typeface="Roboto Mono" pitchFamily="49" charset="0"/>
-              </a:rPr>
-              <a:t>}</a:t>
-            </a:r>
-          </a:p>
-          <a:p>
-            <a:endParaRPr kumimoji="0" lang="en-TH" altLang="en-TH" sz="1200" i="0" u="none" strike="noStrike" cap="none" normalizeH="0" baseline="0" dirty="0">
-              <a:ln>
-                <a:noFill/>
-              </a:ln>
-              <a:effectLst/>
-              <a:latin typeface="Roboto Mono" pitchFamily="49" charset="0"/>
-              <a:ea typeface="Roboto Mono" pitchFamily="49" charset="0"/>
-            </a:endParaRPr>
-          </a:p>
-        </p:txBody>
-      </p:sp>
-      <p:sp>
-        <p:nvSpPr>
-          <p:cNvPr id="6" name="TextBox 5">
-            <a:extLst>
-              <a:ext uri="{FF2B5EF4-FFF2-40B4-BE49-F238E27FC236}">
-                <a16:creationId xmlns:a16="http://schemas.microsoft.com/office/drawing/2014/main" id="{A041981E-C6B4-E838-D055-11FCE4C2F56E}"/>
-              </a:ext>
-            </a:extLst>
-          </p:cNvPr>
-          <p:cNvSpPr txBox="1"/>
-          <p:nvPr/>
-        </p:nvSpPr>
-        <p:spPr>
-          <a:xfrm>
-            <a:off x="5530242" y="2389587"/>
-            <a:ext cx="3475972" cy="307777"/>
-          </a:xfrm>
-          <a:prstGeom prst="rect">
-            <a:avLst/>
-          </a:prstGeom>
-          <a:noFill/>
-        </p:spPr>
-        <p:txBody>
-          <a:bodyPr wrap="square">
-            <a:spAutoFit/>
-          </a:bodyPr>
-          <a:lstStyle/>
-          <a:p>
-            <a:r>
-              <a:rPr lang="en-TH" sz="1400" b="1" dirty="0">
+              <a:t>#!</a:t>
+            </a:r>
+            <a:r>
+              <a:rPr lang="en-US" sz="600" b="1" dirty="0" err="1">
                 <a:solidFill>
                   <a:srgbClr val="FF0000"/>
                 </a:solidFill>
                 <a:latin typeface="Roboto Mono" pitchFamily="49" charset="0"/>
                 <a:ea typeface="Roboto Mono" pitchFamily="49" charset="0"/>
               </a:rPr>
-              <a:t>similar to Maybe::None</a:t>
-            </a:r>
-            <a:endParaRPr lang="en-TH" sz="1400" b="1" dirty="0">
+              <a:t>main.go</a:t>
+            </a:r>
+            <a:endParaRPr lang="en-US" sz="600" b="1" dirty="0">
               <a:solidFill>
                 <a:srgbClr val="FF0000"/>
               </a:solidFill>
+              <a:latin typeface="Roboto Mono" pitchFamily="49" charset="0"/>
+              <a:ea typeface="Roboto Mono" pitchFamily="49" charset="0"/>
             </a:endParaRPr>
+          </a:p>
+          <a:p>
+            <a:endParaRPr lang="en-US" sz="600" dirty="0">
+              <a:latin typeface="Roboto Mono" pitchFamily="49" charset="0"/>
+              <a:ea typeface="Roboto Mono" pitchFamily="49" charset="0"/>
+            </a:endParaRPr>
+          </a:p>
+          <a:p>
+            <a:r>
+              <a:rPr lang="en-US" sz="600" dirty="0">
+                <a:latin typeface="Roboto Mono" pitchFamily="49" charset="0"/>
+                <a:ea typeface="Roboto Mono" pitchFamily="49" charset="0"/>
+              </a:rPr>
+              <a:t>package main</a:t>
+            </a:r>
+            <a:br>
+              <a:rPr lang="en-US" sz="600" dirty="0">
+                <a:latin typeface="Roboto Mono" pitchFamily="49" charset="0"/>
+                <a:ea typeface="Roboto Mono" pitchFamily="49" charset="0"/>
+              </a:rPr>
+            </a:br>
+            <a:endParaRPr lang="en-US" sz="600" dirty="0">
+              <a:latin typeface="Roboto Mono" pitchFamily="49" charset="0"/>
+              <a:ea typeface="Roboto Mono" pitchFamily="49" charset="0"/>
+            </a:endParaRPr>
+          </a:p>
+          <a:p>
+            <a:r>
+              <a:rPr lang="en-US" sz="600" dirty="0">
+                <a:latin typeface="Roboto Mono" pitchFamily="49" charset="0"/>
+                <a:ea typeface="Roboto Mono" pitchFamily="49" charset="0"/>
+              </a:rPr>
+              <a:t>import (</a:t>
+            </a:r>
+          </a:p>
+          <a:p>
+            <a:pPr lvl="1"/>
+            <a:r>
+              <a:rPr lang="en-US" sz="600" dirty="0">
+                <a:latin typeface="Roboto Mono" pitchFamily="49" charset="0"/>
+                <a:ea typeface="Roboto Mono" pitchFamily="49" charset="0"/>
+              </a:rPr>
+              <a:t>"flag"</a:t>
+            </a:r>
+          </a:p>
+          <a:p>
+            <a:pPr lvl="1"/>
+            <a:r>
+              <a:rPr lang="en-US" sz="600" dirty="0">
+                <a:latin typeface="Roboto Mono" pitchFamily="49" charset="0"/>
+                <a:ea typeface="Roboto Mono" pitchFamily="49" charset="0"/>
+              </a:rPr>
+              <a:t>"</a:t>
+            </a:r>
+            <a:r>
+              <a:rPr lang="en-US" sz="600" dirty="0" err="1">
+                <a:latin typeface="Roboto Mono" pitchFamily="49" charset="0"/>
+                <a:ea typeface="Roboto Mono" pitchFamily="49" charset="0"/>
+              </a:rPr>
+              <a:t>fmt</a:t>
+            </a:r>
+            <a:r>
+              <a:rPr lang="en-US" sz="600" dirty="0">
+                <a:latin typeface="Roboto Mono" pitchFamily="49" charset="0"/>
+                <a:ea typeface="Roboto Mono" pitchFamily="49" charset="0"/>
+              </a:rPr>
+              <a:t>"</a:t>
+            </a:r>
+          </a:p>
+          <a:p>
+            <a:pPr lvl="1"/>
+            <a:r>
+              <a:rPr lang="en-US" sz="600" dirty="0">
+                <a:latin typeface="Roboto Mono" pitchFamily="49" charset="0"/>
+                <a:ea typeface="Roboto Mono" pitchFamily="49" charset="0"/>
+              </a:rPr>
+              <a:t>"</a:t>
+            </a:r>
+            <a:r>
+              <a:rPr lang="en-US" sz="600" dirty="0" err="1">
+                <a:latin typeface="Roboto Mono" pitchFamily="49" charset="0"/>
+                <a:ea typeface="Roboto Mono" pitchFamily="49" charset="0"/>
+              </a:rPr>
+              <a:t>os</a:t>
+            </a:r>
+            <a:r>
+              <a:rPr lang="en-US" sz="600" dirty="0">
+                <a:latin typeface="Roboto Mono" pitchFamily="49" charset="0"/>
+                <a:ea typeface="Roboto Mono" pitchFamily="49" charset="0"/>
+              </a:rPr>
+              <a:t>"</a:t>
+            </a:r>
+          </a:p>
+          <a:p>
+            <a:pPr lvl="1"/>
+            <a:r>
+              <a:rPr lang="en-US" sz="600" dirty="0">
+                <a:latin typeface="Roboto Mono" pitchFamily="49" charset="0"/>
+                <a:ea typeface="Roboto Mono" pitchFamily="49" charset="0"/>
+              </a:rPr>
+              <a:t>"ppt-probe/</a:t>
+            </a:r>
+            <a:r>
+              <a:rPr lang="en-US" sz="600" dirty="0" err="1">
+                <a:latin typeface="Roboto Mono" pitchFamily="49" charset="0"/>
+                <a:ea typeface="Roboto Mono" pitchFamily="49" charset="0"/>
+              </a:rPr>
+              <a:t>src</a:t>
+            </a:r>
+            <a:r>
+              <a:rPr lang="en-US" sz="600" dirty="0">
+                <a:latin typeface="Roboto Mono" pitchFamily="49" charset="0"/>
+                <a:ea typeface="Roboto Mono" pitchFamily="49" charset="0"/>
+              </a:rPr>
+              <a:t>/extractor"</a:t>
+            </a:r>
+          </a:p>
+          <a:p>
+            <a:pPr lvl="1"/>
+            <a:r>
+              <a:rPr lang="en-US" sz="600" dirty="0">
+                <a:latin typeface="Roboto Mono" pitchFamily="49" charset="0"/>
+                <a:ea typeface="Roboto Mono" pitchFamily="49" charset="0"/>
+              </a:rPr>
+              <a:t>"ppt-probe/</a:t>
+            </a:r>
+            <a:r>
+              <a:rPr lang="en-US" sz="600" dirty="0" err="1">
+                <a:latin typeface="Roboto Mono" pitchFamily="49" charset="0"/>
+                <a:ea typeface="Roboto Mono" pitchFamily="49" charset="0"/>
+              </a:rPr>
+              <a:t>src</a:t>
+            </a:r>
+            <a:r>
+              <a:rPr lang="en-US" sz="600" dirty="0">
+                <a:latin typeface="Roboto Mono" pitchFamily="49" charset="0"/>
+                <a:ea typeface="Roboto Mono" pitchFamily="49" charset="0"/>
+              </a:rPr>
+              <a:t>/models"</a:t>
+            </a:r>
+          </a:p>
+          <a:p>
+            <a:r>
+              <a:rPr lang="en-US" sz="600" dirty="0">
+                <a:latin typeface="Roboto Mono" pitchFamily="49" charset="0"/>
+                <a:ea typeface="Roboto Mono" pitchFamily="49" charset="0"/>
+              </a:rPr>
+              <a:t>)</a:t>
+            </a:r>
+          </a:p>
+          <a:p>
+            <a:endParaRPr lang="en-US" sz="600" dirty="0">
+              <a:latin typeface="Roboto Mono" pitchFamily="49" charset="0"/>
+              <a:ea typeface="Roboto Mono" pitchFamily="49" charset="0"/>
+            </a:endParaRPr>
+          </a:p>
+          <a:p>
+            <a:r>
+              <a:rPr lang="en-US" sz="600" dirty="0" err="1">
+                <a:latin typeface="Roboto Mono" pitchFamily="49" charset="0"/>
+                <a:ea typeface="Roboto Mono" pitchFamily="49" charset="0"/>
+              </a:rPr>
+              <a:t>func</a:t>
+            </a:r>
+            <a:r>
+              <a:rPr lang="en-US" sz="600" dirty="0">
+                <a:latin typeface="Roboto Mono" pitchFamily="49" charset="0"/>
+                <a:ea typeface="Roboto Mono" pitchFamily="49" charset="0"/>
+              </a:rPr>
+              <a:t> main() {</a:t>
+            </a:r>
+          </a:p>
+          <a:p>
+            <a:endParaRPr lang="en-US" sz="600" dirty="0">
+              <a:latin typeface="Roboto Mono" pitchFamily="49" charset="0"/>
+              <a:ea typeface="Roboto Mono" pitchFamily="49" charset="0"/>
+            </a:endParaRPr>
+          </a:p>
+        </p:txBody>
+      </p:sp>
+      <p:sp>
+        <p:nvSpPr>
+          <p:cNvPr id="16" name="Rectangle 1">
+            <a:extLst>
+              <a:ext uri="{FF2B5EF4-FFF2-40B4-BE49-F238E27FC236}">
+                <a16:creationId xmlns:a16="http://schemas.microsoft.com/office/drawing/2014/main" id="{212D7BC6-2939-7CFC-42F8-AB8575FE9E53}"/>
+              </a:ext>
+            </a:extLst>
+          </p:cNvPr>
+          <p:cNvSpPr>
+            <a:spLocks noChangeArrowheads="1"/>
+          </p:cNvSpPr>
+          <p:nvPr/>
+        </p:nvSpPr>
+        <p:spPr bwMode="auto">
+          <a:xfrm>
+            <a:off x="168964" y="3841651"/>
+            <a:ext cx="2286000" cy="167355"/>
+          </a:xfrm>
+          <a:prstGeom prst="rect">
+            <a:avLst/>
+          </a:prstGeom>
+          <a:solidFill>
+            <a:srgbClr val="F8F6E3"/>
+          </a:solidFill>
+          <a:ln>
+            <a:noFill/>
+          </a:ln>
+          <a:effectLst/>
+        </p:spPr>
+        <p:txBody>
+          <a:bodyPr vert="horz" wrap="square" lIns="74295" tIns="37148" rIns="74295" bIns="37148" numCol="1" anchor="ctr" anchorCtr="0" compatLnSpc="1">
+            <a:prstTxWarp prst="textNoShape">
+              <a:avLst/>
+            </a:prstTxWarp>
+            <a:spAutoFit/>
+          </a:bodyPr>
+          <a:lstStyle>
+            <a:lvl1pPr eaLnBrk="0" fontAlgn="base" hangingPunct="0">
+              <a:spcBef>
+                <a:spcPct val="0"/>
+              </a:spcBef>
+              <a:spcAft>
+                <a:spcPct val="0"/>
+              </a:spcAft>
+              <a:defRPr>
+                <a:solidFill>
+                  <a:schemeClr val="tx1"/>
+                </a:solidFill>
+                <a:latin typeface="Arial" panose="020B0604020202020204" pitchFamily="34" charset="0"/>
+              </a:defRPr>
+            </a:lvl1pPr>
+            <a:lvl2pPr eaLnBrk="0" fontAlgn="base" hangingPunct="0">
+              <a:spcBef>
+                <a:spcPct val="0"/>
+              </a:spcBef>
+              <a:spcAft>
+                <a:spcPct val="0"/>
+              </a:spcAft>
+              <a:defRPr>
+                <a:solidFill>
+                  <a:schemeClr val="tx1"/>
+                </a:solidFill>
+                <a:latin typeface="Arial" panose="020B0604020202020204" pitchFamily="34" charset="0"/>
+              </a:defRPr>
+            </a:lvl2pPr>
+            <a:lvl3pPr eaLnBrk="0" fontAlgn="base" hangingPunct="0">
+              <a:spcBef>
+                <a:spcPct val="0"/>
+              </a:spcBef>
+              <a:spcAft>
+                <a:spcPct val="0"/>
+              </a:spcAft>
+              <a:defRPr>
+                <a:solidFill>
+                  <a:schemeClr val="tx1"/>
+                </a:solidFill>
+                <a:latin typeface="Arial" panose="020B0604020202020204" pitchFamily="34" charset="0"/>
+              </a:defRPr>
+            </a:lvl3pPr>
+            <a:lvl4pPr eaLnBrk="0" fontAlgn="base" hangingPunct="0">
+              <a:spcBef>
+                <a:spcPct val="0"/>
+              </a:spcBef>
+              <a:spcAft>
+                <a:spcPct val="0"/>
+              </a:spcAft>
+              <a:defRPr>
+                <a:solidFill>
+                  <a:schemeClr val="tx1"/>
+                </a:solidFill>
+                <a:latin typeface="Arial" panose="020B0604020202020204" pitchFamily="34" charset="0"/>
+              </a:defRPr>
+            </a:lvl4pPr>
+            <a:lvl5pPr eaLnBrk="0" fontAlgn="base" hangingPunct="0">
+              <a:spcBef>
+                <a:spcPct val="0"/>
+              </a:spcBef>
+              <a:spcAft>
+                <a:spcPct val="0"/>
+              </a:spcAft>
+              <a:defRPr>
+                <a:solidFill>
+                  <a:schemeClr val="tx1"/>
+                </a:solidFill>
+                <a:latin typeface="Arial" panose="020B0604020202020204" pitchFamily="34" charset="0"/>
+              </a:defRPr>
+            </a:lvl5pPr>
+            <a:lvl6pPr eaLnBrk="0" fontAlgn="base" hangingPunct="0">
+              <a:spcBef>
+                <a:spcPct val="0"/>
+              </a:spcBef>
+              <a:spcAft>
+                <a:spcPct val="0"/>
+              </a:spcAft>
+              <a:defRPr>
+                <a:solidFill>
+                  <a:schemeClr val="tx1"/>
+                </a:solidFill>
+                <a:latin typeface="Arial" panose="020B0604020202020204" pitchFamily="34" charset="0"/>
+              </a:defRPr>
+            </a:lvl6pPr>
+            <a:lvl7pPr eaLnBrk="0" fontAlgn="base" hangingPunct="0">
+              <a:spcBef>
+                <a:spcPct val="0"/>
+              </a:spcBef>
+              <a:spcAft>
+                <a:spcPct val="0"/>
+              </a:spcAft>
+              <a:defRPr>
+                <a:solidFill>
+                  <a:schemeClr val="tx1"/>
+                </a:solidFill>
+                <a:latin typeface="Arial" panose="020B0604020202020204" pitchFamily="34" charset="0"/>
+              </a:defRPr>
+            </a:lvl7pPr>
+            <a:lvl8pPr eaLnBrk="0" fontAlgn="base" hangingPunct="0">
+              <a:spcBef>
+                <a:spcPct val="0"/>
+              </a:spcBef>
+              <a:spcAft>
+                <a:spcPct val="0"/>
+              </a:spcAft>
+              <a:defRPr>
+                <a:solidFill>
+                  <a:schemeClr val="tx1"/>
+                </a:solidFill>
+                <a:latin typeface="Arial" panose="020B0604020202020204" pitchFamily="34" charset="0"/>
+              </a:defRPr>
+            </a:lvl8pPr>
+            <a:lvl9pPr eaLnBrk="0" fontAlgn="base" hangingPunct="0">
+              <a:spcBef>
+                <a:spcPct val="0"/>
+              </a:spcBef>
+              <a:spcAft>
+                <a:spcPct val="0"/>
+              </a:spcAft>
+              <a:defRPr>
+                <a:solidFill>
+                  <a:schemeClr val="tx1"/>
+                </a:solidFill>
+                <a:latin typeface="Arial" panose="020B0604020202020204" pitchFamily="34" charset="0"/>
+              </a:defRPr>
+            </a:lvl9pPr>
+          </a:lstStyle>
+          <a:p>
+            <a:r>
+              <a:rPr lang="en-US" sz="600" dirty="0">
+                <a:latin typeface="Roboto Mono" pitchFamily="49" charset="0"/>
+                <a:ea typeface="Roboto Mono" pitchFamily="49" charset="0"/>
+              </a:rPr>
+              <a:t>}</a:t>
+            </a:r>
           </a:p>
         </p:txBody>
       </p:sp>
       <p:cxnSp>
         <p:nvCxnSpPr>
-          <p:cNvPr id="3" name="Straight Arrow Connector 2">
+          <p:cNvPr id="19" name="Straight Arrow Connector 18">
             <a:extLst>
               <a:ext uri="{FF2B5EF4-FFF2-40B4-BE49-F238E27FC236}">
-                <a16:creationId xmlns:a16="http://schemas.microsoft.com/office/drawing/2014/main" id="{BB32C78D-2D90-BCDA-E851-16BBC686186C}"/>
+                <a16:creationId xmlns:a16="http://schemas.microsoft.com/office/drawing/2014/main" id="{243EF48A-DB77-D475-1BCD-84062099F4CD}"/>
               </a:ext>
             </a:extLst>
           </p:cNvPr>
           <p:cNvCxnSpPr>
-            <a:cxnSpLocks/>
             <a:stCxn id="5" idx="2"/>
-            <a:endCxn id="10" idx="0"/>
+            <a:endCxn id="16" idx="0"/>
           </p:cNvCxnSpPr>
           <p:nvPr/>
         </p:nvCxnSpPr>
         <p:spPr>
           <a:xfrm>
-            <a:off x="3671527" y="4190080"/>
-            <a:ext cx="0" cy="503482"/>
-          </a:xfrm>
-          <a:prstGeom prst="straightConnector1">
-            <a:avLst/>
-          </a:prstGeom>
-          <a:ln>
-            <a:solidFill>
-              <a:schemeClr val="bg1">
-                <a:lumMod val="85000"/>
-              </a:schemeClr>
-            </a:solidFill>
-            <a:tailEnd type="triangle"/>
-          </a:ln>
-        </p:spPr>
-        <p:style>
-          <a:lnRef idx="2">
-            <a:schemeClr val="dk1"/>
-          </a:lnRef>
-          <a:fillRef idx="0">
-            <a:schemeClr val="dk1"/>
-          </a:fillRef>
-          <a:effectRef idx="1">
-            <a:schemeClr val="dk1"/>
-          </a:effectRef>
-          <a:fontRef idx="minor">
-            <a:schemeClr val="tx1"/>
-          </a:fontRef>
-        </p:style>
-      </p:cxnSp>
-      <p:sp>
-        <p:nvSpPr>
-          <p:cNvPr id="10" name="TextBox 9">
-            <a:extLst>
-              <a:ext uri="{FF2B5EF4-FFF2-40B4-BE49-F238E27FC236}">
-                <a16:creationId xmlns:a16="http://schemas.microsoft.com/office/drawing/2014/main" id="{A67742F2-6B00-5C92-1420-DF3A412E6610}"/>
-              </a:ext>
-            </a:extLst>
-          </p:cNvPr>
-          <p:cNvSpPr txBox="1"/>
-          <p:nvPr/>
-        </p:nvSpPr>
-        <p:spPr>
-          <a:xfrm>
-            <a:off x="596388" y="4693562"/>
-            <a:ext cx="6150278" cy="1600438"/>
-          </a:xfrm>
-          <a:prstGeom prst="rect">
-            <a:avLst/>
-          </a:prstGeom>
-          <a:solidFill>
-            <a:schemeClr val="accent6">
-              <a:lumMod val="20000"/>
-              <a:lumOff val="80000"/>
-            </a:schemeClr>
-          </a:solidFill>
-        </p:spPr>
-        <p:txBody>
-          <a:bodyPr wrap="square">
-            <a:spAutoFit/>
-          </a:bodyPr>
-          <a:lstStyle/>
-          <a:p>
-            <a:r>
-              <a:rPr lang="en-TH" altLang="en-TH" sz="1400" b="1" dirty="0">
-                <a:solidFill>
-                  <a:srgbClr val="C00000"/>
-                </a:solidFill>
-                <a:latin typeface="Roboto Mono" pitchFamily="49" charset="0"/>
-                <a:ea typeface="Roboto Mono" pitchFamily="49" charset="0"/>
-              </a:rPr>
-              <a:t>class </a:t>
-            </a:r>
-            <a:r>
-              <a:rPr lang="en-TH" altLang="en-TH" sz="1400" b="1" dirty="0">
-                <a:solidFill>
-                  <a:schemeClr val="accent2">
-                    <a:lumMod val="50000"/>
-                  </a:schemeClr>
-                </a:solidFill>
-                <a:latin typeface="Roboto Mono" pitchFamily="49" charset="0"/>
-                <a:ea typeface="Roboto Mono" pitchFamily="49" charset="0"/>
-              </a:rPr>
-              <a:t>Sentinel</a:t>
-            </a:r>
-            <a:r>
-              <a:rPr lang="en-TH" altLang="en-TH" sz="1400" dirty="0">
-                <a:latin typeface="Roboto Mono" pitchFamily="49" charset="0"/>
-                <a:ea typeface="Roboto Mono" pitchFamily="49" charset="0"/>
-              </a:rPr>
-              <a:t> extends </a:t>
-            </a:r>
-            <a:r>
-              <a:rPr lang="en-TH" altLang="en-TH" sz="1400" b="1" dirty="0">
-                <a:solidFill>
-                  <a:schemeClr val="accent5">
-                    <a:lumMod val="50000"/>
-                  </a:schemeClr>
-                </a:solidFill>
-                <a:latin typeface="Roboto Mono" pitchFamily="49" charset="0"/>
-                <a:ea typeface="Roboto Mono" pitchFamily="49" charset="0"/>
-              </a:rPr>
-              <a:t>InfiniteList</a:t>
-            </a:r>
-            <a:r>
-              <a:rPr lang="en-TH" altLang="en-TH" sz="1400" dirty="0">
-                <a:latin typeface="Roboto Mono" pitchFamily="49" charset="0"/>
-                <a:ea typeface="Roboto Mono" pitchFamily="49" charset="0"/>
-              </a:rPr>
-              <a:t>&lt;</a:t>
-            </a:r>
-            <a:r>
-              <a:rPr lang="en-TH" altLang="en-TH" sz="1400" b="1" dirty="0">
-                <a:solidFill>
-                  <a:srgbClr val="C00000"/>
-                </a:solidFill>
-                <a:latin typeface="Roboto Mono" pitchFamily="49" charset="0"/>
-                <a:ea typeface="Roboto Mono" pitchFamily="49" charset="0"/>
-              </a:rPr>
-              <a:t>Object</a:t>
-            </a:r>
-            <a:r>
-              <a:rPr lang="en-TH" altLang="en-TH" sz="1400" dirty="0">
-                <a:latin typeface="Roboto Mono" pitchFamily="49" charset="0"/>
-                <a:ea typeface="Roboto Mono" pitchFamily="49" charset="0"/>
-              </a:rPr>
-              <a:t>&gt; {</a:t>
-            </a:r>
-          </a:p>
-          <a:p>
-            <a:endParaRPr lang="en-TH" altLang="en-TH" sz="1400" dirty="0">
-              <a:latin typeface="Roboto Mono" pitchFamily="49" charset="0"/>
-              <a:ea typeface="Roboto Mono" pitchFamily="49" charset="0"/>
-            </a:endParaRPr>
-          </a:p>
-          <a:p>
-            <a:r>
-              <a:rPr lang="en-US" altLang="en-TH" sz="1400" dirty="0">
-                <a:latin typeface="Roboto Mono" pitchFamily="49" charset="0"/>
-                <a:ea typeface="Roboto Mono" pitchFamily="49" charset="0"/>
-              </a:rPr>
-              <a:t>    </a:t>
-            </a:r>
-            <a:r>
-              <a:rPr lang="en-US" altLang="en-TH" sz="1400" b="1" dirty="0">
-                <a:latin typeface="Roboto Mono" pitchFamily="49" charset="0"/>
-                <a:ea typeface="Roboto Mono" pitchFamily="49" charset="0"/>
-              </a:rPr>
-              <a:t>@Override</a:t>
-            </a:r>
-          </a:p>
-          <a:p>
-            <a:r>
-              <a:rPr lang="en-US" altLang="en-TH" sz="1400" dirty="0">
-                <a:latin typeface="Roboto Mono" pitchFamily="49" charset="0"/>
-                <a:ea typeface="Roboto Mono" pitchFamily="49" charset="0"/>
-              </a:rPr>
-              <a:t>    public </a:t>
-            </a:r>
-            <a:r>
-              <a:rPr lang="en-US" altLang="en-TH" sz="1400" dirty="0" err="1">
-                <a:latin typeface="Roboto Mono" pitchFamily="49" charset="0"/>
-                <a:ea typeface="Roboto Mono" pitchFamily="49" charset="0"/>
-              </a:rPr>
-              <a:t>boolean</a:t>
-            </a:r>
-            <a:r>
-              <a:rPr lang="en-US" altLang="en-TH" sz="1400" dirty="0">
-                <a:latin typeface="Roboto Mono" pitchFamily="49" charset="0"/>
-                <a:ea typeface="Roboto Mono" pitchFamily="49" charset="0"/>
-              </a:rPr>
-              <a:t> </a:t>
-            </a:r>
-            <a:r>
-              <a:rPr lang="en-US" altLang="en-TH" sz="1400" dirty="0" err="1">
-                <a:latin typeface="Roboto Mono" pitchFamily="49" charset="0"/>
-                <a:ea typeface="Roboto Mono" pitchFamily="49" charset="0"/>
-              </a:rPr>
-              <a:t>isSentinel</a:t>
-            </a:r>
-            <a:r>
-              <a:rPr lang="en-US" altLang="en-TH" sz="1400" dirty="0">
-                <a:latin typeface="Roboto Mono" pitchFamily="49" charset="0"/>
-                <a:ea typeface="Roboto Mono" pitchFamily="49" charset="0"/>
-              </a:rPr>
-              <a:t>() {</a:t>
-            </a:r>
-          </a:p>
-          <a:p>
-            <a:r>
-              <a:rPr lang="en-US" altLang="en-TH" sz="1400" dirty="0">
-                <a:latin typeface="Roboto Mono" pitchFamily="49" charset="0"/>
-                <a:ea typeface="Roboto Mono" pitchFamily="49" charset="0"/>
-              </a:rPr>
-              <a:t>      return true;</a:t>
-            </a:r>
-          </a:p>
-          <a:p>
-            <a:r>
-              <a:rPr lang="en-US" altLang="en-TH" sz="1400" dirty="0">
-                <a:latin typeface="Roboto Mono" pitchFamily="49" charset="0"/>
-                <a:ea typeface="Roboto Mono" pitchFamily="49" charset="0"/>
-              </a:rPr>
-              <a:t>    }</a:t>
-            </a:r>
-            <a:endParaRPr lang="en-TH" altLang="en-TH" sz="1400" dirty="0">
-              <a:latin typeface="Roboto Mono" pitchFamily="49" charset="0"/>
-              <a:ea typeface="Roboto Mono" pitchFamily="49" charset="0"/>
-            </a:endParaRPr>
-          </a:p>
-          <a:p>
-            <a:r>
-              <a:rPr lang="en-TH" altLang="en-TH" sz="1400" dirty="0">
-                <a:latin typeface="Roboto Mono" pitchFamily="49" charset="0"/>
-                <a:ea typeface="Roboto Mono" pitchFamily="49" charset="0"/>
-              </a:rPr>
-              <a:t>}</a:t>
-            </a:r>
-          </a:p>
-        </p:txBody>
-      </p:sp>
-      <p:cxnSp>
-        <p:nvCxnSpPr>
-          <p:cNvPr id="15" name="Straight Arrow Connector 14">
-            <a:extLst>
-              <a:ext uri="{FF2B5EF4-FFF2-40B4-BE49-F238E27FC236}">
-                <a16:creationId xmlns:a16="http://schemas.microsoft.com/office/drawing/2014/main" id="{E223A480-3B1E-6F31-8BCB-CC18C3A5D60E}"/>
-              </a:ext>
-            </a:extLst>
-          </p:cNvPr>
-          <p:cNvCxnSpPr>
-            <a:cxnSpLocks/>
-            <a:endCxn id="5" idx="0"/>
-          </p:cNvCxnSpPr>
-          <p:nvPr/>
-        </p:nvCxnSpPr>
-        <p:spPr>
-          <a:xfrm flipH="1">
-            <a:off x="3671527" y="837983"/>
-            <a:ext cx="1" cy="120443"/>
-          </a:xfrm>
-          <a:prstGeom prst="straightConnector1">
-            <a:avLst/>
-          </a:prstGeom>
-          <a:ln>
-            <a:solidFill>
-              <a:schemeClr val="bg1">
-                <a:lumMod val="85000"/>
-              </a:schemeClr>
-            </a:solidFill>
-            <a:tailEnd type="triangle"/>
-          </a:ln>
-        </p:spPr>
-        <p:style>
-          <a:lnRef idx="2">
-            <a:schemeClr val="dk1"/>
-          </a:lnRef>
-          <a:fillRef idx="0">
-            <a:schemeClr val="dk1"/>
-          </a:fillRef>
-          <a:effectRef idx="1">
-            <a:schemeClr val="dk1"/>
-          </a:effectRef>
-          <a:fontRef idx="minor">
-            <a:schemeClr val="tx1"/>
-          </a:fontRef>
-        </p:style>
-      </p:cxnSp>
-      <p:graphicFrame>
-        <p:nvGraphicFramePr>
-          <p:cNvPr id="18" name="Table 17">
-            <a:extLst>
-              <a:ext uri="{FF2B5EF4-FFF2-40B4-BE49-F238E27FC236}">
-                <a16:creationId xmlns:a16="http://schemas.microsoft.com/office/drawing/2014/main" id="{4C60ECEF-5A10-9A73-57BC-086273F00C39}"/>
-              </a:ext>
-            </a:extLst>
-          </p:cNvPr>
-          <p:cNvGraphicFramePr>
-            <a:graphicFrameLocks noGrp="1"/>
-          </p:cNvGraphicFramePr>
-          <p:nvPr>
-            <p:extLst>
-              <p:ext uri="{D42A27DB-BD31-4B8C-83A1-F6EECF244321}">
-                <p14:modId xmlns:p14="http://schemas.microsoft.com/office/powerpoint/2010/main" val="3502278822"/>
-              </p:ext>
-            </p:extLst>
-          </p:nvPr>
-        </p:nvGraphicFramePr>
-        <p:xfrm>
-          <a:off x="5314671" y="3548515"/>
-          <a:ext cx="5228610" cy="370840"/>
-        </p:xfrm>
-        <a:graphic>
-          <a:graphicData uri="http://schemas.openxmlformats.org/drawingml/2006/table">
-            <a:tbl>
-              <a:tblPr firstRow="1" bandRow="1">
-                <a:tableStyleId>{5C22544A-7EE6-4342-B048-85BDC9FD1C3A}</a:tableStyleId>
-              </a:tblPr>
-              <a:tblGrid>
-                <a:gridCol w="871435">
-                  <a:extLst>
-                    <a:ext uri="{9D8B030D-6E8A-4147-A177-3AD203B41FA5}">
-                      <a16:colId xmlns:a16="http://schemas.microsoft.com/office/drawing/2014/main" val="3195948067"/>
-                    </a:ext>
-                  </a:extLst>
-                </a:gridCol>
-                <a:gridCol w="871435">
-                  <a:extLst>
-                    <a:ext uri="{9D8B030D-6E8A-4147-A177-3AD203B41FA5}">
-                      <a16:colId xmlns:a16="http://schemas.microsoft.com/office/drawing/2014/main" val="2112097517"/>
-                    </a:ext>
-                  </a:extLst>
-                </a:gridCol>
-                <a:gridCol w="871435">
-                  <a:extLst>
-                    <a:ext uri="{9D8B030D-6E8A-4147-A177-3AD203B41FA5}">
-                      <a16:colId xmlns:a16="http://schemas.microsoft.com/office/drawing/2014/main" val="4019402721"/>
-                    </a:ext>
-                  </a:extLst>
-                </a:gridCol>
-                <a:gridCol w="871435">
-                  <a:extLst>
-                    <a:ext uri="{9D8B030D-6E8A-4147-A177-3AD203B41FA5}">
-                      <a16:colId xmlns:a16="http://schemas.microsoft.com/office/drawing/2014/main" val="1450968658"/>
-                    </a:ext>
-                  </a:extLst>
-                </a:gridCol>
-                <a:gridCol w="871435">
-                  <a:extLst>
-                    <a:ext uri="{9D8B030D-6E8A-4147-A177-3AD203B41FA5}">
-                      <a16:colId xmlns:a16="http://schemas.microsoft.com/office/drawing/2014/main" val="59210150"/>
-                    </a:ext>
-                  </a:extLst>
-                </a:gridCol>
-                <a:gridCol w="871435">
-                  <a:extLst>
-                    <a:ext uri="{9D8B030D-6E8A-4147-A177-3AD203B41FA5}">
-                      <a16:colId xmlns:a16="http://schemas.microsoft.com/office/drawing/2014/main" val="236189149"/>
-                    </a:ext>
-                  </a:extLst>
-                </a:gridCol>
-              </a:tblGrid>
-              <a:tr h="370840">
-                <a:tc>
-                  <a:txBody>
-                    <a:bodyPr/>
-                    <a:lstStyle/>
-                    <a:p>
-                      <a:pPr algn="ctr"/>
-                      <a:r>
-                        <a:rPr lang="en-TH" dirty="0">
-                          <a:solidFill>
-                            <a:schemeClr val="tx2">
-                              <a:lumMod val="50000"/>
-                            </a:schemeClr>
-                          </a:solidFill>
-                          <a:latin typeface="Roboto Mono" pitchFamily="49" charset="0"/>
-                          <a:ea typeface="Roboto Mono" pitchFamily="49" charset="0"/>
-                        </a:rPr>
-                        <a:t>[5]</a:t>
-                      </a:r>
-                    </a:p>
-                  </a:txBody>
-                  <a:tcPr>
-                    <a:lnL w="12700" cap="flat" cmpd="sng" algn="ctr">
-                      <a:solidFill>
-                        <a:schemeClr val="tx1"/>
-                      </a:solidFill>
-                      <a:prstDash val="solid"/>
-                      <a:round/>
-                      <a:headEnd type="none" w="med" len="med"/>
-                      <a:tailEnd type="none" w="med" len="med"/>
-                    </a:lnL>
-                    <a:lnR w="12700" cap="flat" cmpd="sng" algn="ctr">
-                      <a:solidFill>
-                        <a:schemeClr val="tx1"/>
-                      </a:solidFill>
-                      <a:prstDash val="solid"/>
-                      <a:round/>
-                      <a:headEnd type="none" w="med" len="med"/>
-                      <a:tailEnd type="none" w="med" len="med"/>
-                    </a:lnR>
-                    <a:lnT w="12700" cap="flat" cmpd="sng" algn="ctr">
-                      <a:solidFill>
-                        <a:schemeClr val="tx1"/>
-                      </a:solidFill>
-                      <a:prstDash val="solid"/>
-                      <a:round/>
-                      <a:headEnd type="none" w="med" len="med"/>
-                      <a:tailEnd type="none" w="med" len="med"/>
-                    </a:lnT>
-                    <a:lnB w="12700" cap="flat" cmpd="sng" algn="ctr">
-                      <a:solidFill>
-                        <a:schemeClr val="tx1"/>
-                      </a:solidFill>
-                      <a:prstDash val="solid"/>
-                      <a:round/>
-                      <a:headEnd type="none" w="med" len="med"/>
-                      <a:tailEnd type="none" w="med" len="med"/>
-                    </a:lnB>
-                    <a:solidFill>
-                      <a:schemeClr val="accent3">
-                        <a:lumMod val="40000"/>
-                        <a:lumOff val="60000"/>
-                      </a:schemeClr>
-                    </a:solidFill>
-                  </a:tcPr>
-                </a:tc>
-                <a:tc>
-                  <a:txBody>
-                    <a:bodyPr/>
-                    <a:lstStyle/>
-                    <a:p>
-                      <a:pPr algn="ctr"/>
-                      <a:r>
-                        <a:rPr lang="en-TH" dirty="0">
-                          <a:solidFill>
-                            <a:schemeClr val="tx2">
-                              <a:lumMod val="50000"/>
-                            </a:schemeClr>
-                          </a:solidFill>
-                          <a:latin typeface="Roboto Mono" pitchFamily="49" charset="0"/>
-                          <a:ea typeface="Roboto Mono" pitchFamily="49" charset="0"/>
-                        </a:rPr>
-                        <a:t>[6]</a:t>
-                      </a:r>
-                    </a:p>
-                  </a:txBody>
-                  <a:tcPr>
-                    <a:lnL w="12700" cap="flat" cmpd="sng" algn="ctr">
-                      <a:solidFill>
-                        <a:schemeClr val="tx1"/>
-                      </a:solidFill>
-                      <a:prstDash val="solid"/>
-                      <a:round/>
-                      <a:headEnd type="none" w="med" len="med"/>
-                      <a:tailEnd type="none" w="med" len="med"/>
-                    </a:lnL>
-                    <a:lnR w="12700" cap="flat" cmpd="sng" algn="ctr">
-                      <a:solidFill>
-                        <a:schemeClr val="tx1"/>
-                      </a:solidFill>
-                      <a:prstDash val="solid"/>
-                      <a:round/>
-                      <a:headEnd type="none" w="med" len="med"/>
-                      <a:tailEnd type="none" w="med" len="med"/>
-                    </a:lnR>
-                    <a:lnT w="12700" cap="flat" cmpd="sng" algn="ctr">
-                      <a:solidFill>
-                        <a:schemeClr val="tx1"/>
-                      </a:solidFill>
-                      <a:prstDash val="solid"/>
-                      <a:round/>
-                      <a:headEnd type="none" w="med" len="med"/>
-                      <a:tailEnd type="none" w="med" len="med"/>
-                    </a:lnT>
-                    <a:lnB w="12700" cap="flat" cmpd="sng" algn="ctr">
-                      <a:solidFill>
-                        <a:schemeClr val="tx1"/>
-                      </a:solidFill>
-                      <a:prstDash val="solid"/>
-                      <a:round/>
-                      <a:headEnd type="none" w="med" len="med"/>
-                      <a:tailEnd type="none" w="med" len="med"/>
-                    </a:lnB>
-                    <a:solidFill>
-                      <a:schemeClr val="bg2">
-                        <a:lumMod val="75000"/>
-                      </a:schemeClr>
-                    </a:solidFill>
-                  </a:tcPr>
-                </a:tc>
-                <a:tc>
-                  <a:txBody>
-                    <a:bodyPr/>
-                    <a:lstStyle/>
-                    <a:p>
-                      <a:pPr algn="ctr"/>
-                      <a:r>
-                        <a:rPr lang="en-TH" dirty="0">
-                          <a:solidFill>
-                            <a:schemeClr val="tx2">
-                              <a:lumMod val="50000"/>
-                            </a:schemeClr>
-                          </a:solidFill>
-                          <a:latin typeface="Roboto Mono" pitchFamily="49" charset="0"/>
-                          <a:ea typeface="Roboto Mono" pitchFamily="49" charset="0"/>
-                        </a:rPr>
-                        <a:t>[ ]</a:t>
-                      </a:r>
-                    </a:p>
-                  </a:txBody>
-                  <a:tcPr>
-                    <a:lnL w="12700" cap="flat" cmpd="sng" algn="ctr">
-                      <a:solidFill>
-                        <a:schemeClr val="tx1"/>
-                      </a:solidFill>
-                      <a:prstDash val="solid"/>
-                      <a:round/>
-                      <a:headEnd type="none" w="med" len="med"/>
-                      <a:tailEnd type="none" w="med" len="med"/>
-                    </a:lnL>
-                    <a:lnR w="12700" cap="flat" cmpd="sng" algn="ctr">
-                      <a:solidFill>
-                        <a:schemeClr val="tx1"/>
-                      </a:solidFill>
-                      <a:prstDash val="solid"/>
-                      <a:round/>
-                      <a:headEnd type="none" w="med" len="med"/>
-                      <a:tailEnd type="none" w="med" len="med"/>
-                    </a:lnR>
-                    <a:lnT w="12700" cap="flat" cmpd="sng" algn="ctr">
-                      <a:solidFill>
-                        <a:schemeClr val="tx1"/>
-                      </a:solidFill>
-                      <a:prstDash val="solid"/>
-                      <a:round/>
-                      <a:headEnd type="none" w="med" len="med"/>
-                      <a:tailEnd type="none" w="med" len="med"/>
-                    </a:lnT>
-                    <a:lnB w="12700" cap="flat" cmpd="sng" algn="ctr">
-                      <a:solidFill>
-                        <a:schemeClr val="tx1"/>
-                      </a:solidFill>
-                      <a:prstDash val="solid"/>
-                      <a:round/>
-                      <a:headEnd type="none" w="med" len="med"/>
-                      <a:tailEnd type="none" w="med" len="med"/>
-                    </a:lnB>
-                    <a:solidFill>
-                      <a:schemeClr val="bg2">
-                        <a:lumMod val="75000"/>
-                      </a:schemeClr>
-                    </a:solidFill>
-                  </a:tcPr>
-                </a:tc>
-                <a:tc>
-                  <a:txBody>
-                    <a:bodyPr/>
-                    <a:lstStyle/>
-                    <a:p>
-                      <a:pPr algn="ctr"/>
-                      <a:r>
-                        <a:rPr lang="en-TH" dirty="0">
-                          <a:solidFill>
-                            <a:schemeClr val="tx2">
-                              <a:lumMod val="50000"/>
-                            </a:schemeClr>
-                          </a:solidFill>
-                          <a:latin typeface="Roboto Mono" pitchFamily="49" charset="0"/>
-                          <a:ea typeface="Roboto Mono" pitchFamily="49" charset="0"/>
-                        </a:rPr>
-                        <a:t>[2]</a:t>
-                      </a:r>
-                    </a:p>
-                  </a:txBody>
-                  <a:tcPr>
-                    <a:lnL w="12700" cap="flat" cmpd="sng" algn="ctr">
-                      <a:solidFill>
-                        <a:schemeClr val="tx1"/>
-                      </a:solidFill>
-                      <a:prstDash val="solid"/>
-                      <a:round/>
-                      <a:headEnd type="none" w="med" len="med"/>
-                      <a:tailEnd type="none" w="med" len="med"/>
-                    </a:lnL>
-                    <a:lnR w="12700" cap="flat" cmpd="sng" algn="ctr">
-                      <a:solidFill>
-                        <a:schemeClr val="tx1"/>
-                      </a:solidFill>
-                      <a:prstDash val="solid"/>
-                      <a:round/>
-                      <a:headEnd type="none" w="med" len="med"/>
-                      <a:tailEnd type="none" w="med" len="med"/>
-                    </a:lnR>
-                    <a:lnT w="12700" cap="flat" cmpd="sng" algn="ctr">
-                      <a:solidFill>
-                        <a:schemeClr val="tx1"/>
-                      </a:solidFill>
-                      <a:prstDash val="solid"/>
-                      <a:round/>
-                      <a:headEnd type="none" w="med" len="med"/>
-                      <a:tailEnd type="none" w="med" len="med"/>
-                    </a:lnT>
-                    <a:lnB w="12700" cap="flat" cmpd="sng" algn="ctr">
-                      <a:solidFill>
-                        <a:schemeClr val="tx1"/>
-                      </a:solidFill>
-                      <a:prstDash val="solid"/>
-                      <a:round/>
-                      <a:headEnd type="none" w="med" len="med"/>
-                      <a:tailEnd type="none" w="med" len="med"/>
-                    </a:lnB>
-                    <a:solidFill>
-                      <a:schemeClr val="bg2">
-                        <a:lumMod val="75000"/>
-                      </a:schemeClr>
-                    </a:solidFill>
-                  </a:tcPr>
-                </a:tc>
-                <a:tc>
-                  <a:txBody>
-                    <a:bodyPr/>
-                    <a:lstStyle/>
-                    <a:p>
-                      <a:pPr algn="ctr"/>
-                      <a:r>
-                        <a:rPr lang="en-TH" dirty="0">
-                          <a:solidFill>
-                            <a:schemeClr val="tx2">
-                              <a:lumMod val="50000"/>
-                            </a:schemeClr>
-                          </a:solidFill>
-                          <a:latin typeface="Roboto Mono" pitchFamily="49" charset="0"/>
-                          <a:ea typeface="Roboto Mono" pitchFamily="49" charset="0"/>
-                        </a:rPr>
-                        <a:t>S</a:t>
-                      </a:r>
-                    </a:p>
-                  </a:txBody>
-                  <a:tcPr>
-                    <a:lnL w="12700" cap="flat" cmpd="sng" algn="ctr">
-                      <a:solidFill>
-                        <a:schemeClr val="tx1"/>
-                      </a:solidFill>
-                      <a:prstDash val="solid"/>
-                      <a:round/>
-                      <a:headEnd type="none" w="med" len="med"/>
-                      <a:tailEnd type="none" w="med" len="med"/>
-                    </a:lnL>
-                    <a:lnR w="12700" cap="flat" cmpd="sng" algn="ctr">
-                      <a:solidFill>
-                        <a:schemeClr val="tx1"/>
-                      </a:solidFill>
-                      <a:prstDash val="solid"/>
-                      <a:round/>
-                      <a:headEnd type="none" w="med" len="med"/>
-                      <a:tailEnd type="none" w="med" len="med"/>
-                    </a:lnR>
-                    <a:lnT w="12700" cap="flat" cmpd="sng" algn="ctr">
-                      <a:solidFill>
-                        <a:schemeClr val="tx1"/>
-                      </a:solidFill>
-                      <a:prstDash val="solid"/>
-                      <a:round/>
-                      <a:headEnd type="none" w="med" len="med"/>
-                      <a:tailEnd type="none" w="med" len="med"/>
-                    </a:lnT>
-                    <a:lnB w="12700" cap="flat" cmpd="sng" algn="ctr">
-                      <a:solidFill>
-                        <a:schemeClr val="tx1"/>
-                      </a:solidFill>
-                      <a:prstDash val="solid"/>
-                      <a:round/>
-                      <a:headEnd type="none" w="med" len="med"/>
-                      <a:tailEnd type="none" w="med" len="med"/>
-                    </a:lnB>
-                    <a:solidFill>
-                      <a:schemeClr val="bg2">
-                        <a:lumMod val="75000"/>
-                      </a:schemeClr>
-                    </a:solidFill>
-                  </a:tcPr>
-                </a:tc>
-                <a:tc>
-                  <a:txBody>
-                    <a:bodyPr/>
-                    <a:lstStyle/>
-                    <a:p>
-                      <a:pPr algn="ctr"/>
-                      <a:r>
-                        <a:rPr lang="en-TH" dirty="0">
-                          <a:solidFill>
-                            <a:schemeClr val="tx2">
-                              <a:lumMod val="50000"/>
-                            </a:schemeClr>
-                          </a:solidFill>
-                          <a:latin typeface="Roboto Mono" pitchFamily="49" charset="0"/>
-                          <a:ea typeface="Roboto Mono" pitchFamily="49" charset="0"/>
-                        </a:rPr>
-                        <a:t>?</a:t>
-                      </a:r>
-                    </a:p>
-                  </a:txBody>
-                  <a:tcPr>
-                    <a:lnL w="12700" cap="flat" cmpd="sng" algn="ctr">
-                      <a:solidFill>
-                        <a:schemeClr val="tx1"/>
-                      </a:solidFill>
-                      <a:prstDash val="solid"/>
-                      <a:round/>
-                      <a:headEnd type="none" w="med" len="med"/>
-                      <a:tailEnd type="none" w="med" len="med"/>
-                    </a:lnL>
-                    <a:lnR w="12700" cap="flat" cmpd="sng" algn="ctr">
-                      <a:solidFill>
-                        <a:schemeClr val="tx1"/>
-                      </a:solidFill>
-                      <a:prstDash val="solid"/>
-                      <a:round/>
-                      <a:headEnd type="none" w="med" len="med"/>
-                      <a:tailEnd type="none" w="med" len="med"/>
-                    </a:lnR>
-                    <a:lnT w="12700" cap="flat" cmpd="sng" algn="ctr">
-                      <a:solidFill>
-                        <a:schemeClr val="tx1"/>
-                      </a:solidFill>
-                      <a:prstDash val="solid"/>
-                      <a:round/>
-                      <a:headEnd type="none" w="med" len="med"/>
-                      <a:tailEnd type="none" w="med" len="med"/>
-                    </a:lnT>
-                    <a:lnB w="12700" cap="flat" cmpd="sng" algn="ctr">
-                      <a:solidFill>
-                        <a:schemeClr val="tx1"/>
-                      </a:solidFill>
-                      <a:prstDash val="solid"/>
-                      <a:round/>
-                      <a:headEnd type="none" w="med" len="med"/>
-                      <a:tailEnd type="none" w="med" len="med"/>
-                    </a:lnB>
-                    <a:solidFill>
-                      <a:schemeClr val="bg2">
-                        <a:lumMod val="75000"/>
-                      </a:schemeClr>
-                    </a:solidFill>
-                  </a:tcPr>
-                </a:tc>
-                <a:extLst>
-                  <a:ext uri="{0D108BD9-81ED-4DB2-BD59-A6C34878D82A}">
-                    <a16:rowId xmlns:a16="http://schemas.microsoft.com/office/drawing/2014/main" val="2986261621"/>
-                  </a:ext>
-                </a:extLst>
-              </a:tr>
-            </a:tbl>
-          </a:graphicData>
-        </a:graphic>
-      </p:graphicFrame>
-      <p:cxnSp>
-        <p:nvCxnSpPr>
-          <p:cNvPr id="20" name="Straight Arrow Connector 19">
-            <a:extLst>
-              <a:ext uri="{FF2B5EF4-FFF2-40B4-BE49-F238E27FC236}">
-                <a16:creationId xmlns:a16="http://schemas.microsoft.com/office/drawing/2014/main" id="{9D48945C-D1A3-7F4D-2583-FFDA1C179831}"/>
-              </a:ext>
-            </a:extLst>
-          </p:cNvPr>
-          <p:cNvCxnSpPr/>
-          <p:nvPr/>
-        </p:nvCxnSpPr>
-        <p:spPr>
-          <a:xfrm>
-            <a:off x="9231682" y="2697364"/>
-            <a:ext cx="0" cy="851151"/>
+            <a:off x="1311964" y="2478884"/>
+            <a:ext cx="0" cy="1362767"/>
           </a:xfrm>
           <a:prstGeom prst="straightConnector1">
             <a:avLst/>
@@ -4656,44 +3570,6 @@
           </a:fontRef>
         </p:style>
       </p:cxnSp>
-      <p:sp>
-        <p:nvSpPr>
-          <p:cNvPr id="21" name="TextBox 20">
-            <a:extLst>
-              <a:ext uri="{FF2B5EF4-FFF2-40B4-BE49-F238E27FC236}">
-                <a16:creationId xmlns:a16="http://schemas.microsoft.com/office/drawing/2014/main" id="{0301B7DE-724C-9804-D7E1-33E105788484}"/>
-              </a:ext>
-            </a:extLst>
-          </p:cNvPr>
-          <p:cNvSpPr txBox="1"/>
-          <p:nvPr/>
-        </p:nvSpPr>
-        <p:spPr>
-          <a:xfrm>
-            <a:off x="8587916" y="2284893"/>
-            <a:ext cx="1287532" cy="369332"/>
-          </a:xfrm>
-          <a:prstGeom prst="rect">
-            <a:avLst/>
-          </a:prstGeom>
-          <a:noFill/>
-        </p:spPr>
-        <p:txBody>
-          <a:bodyPr wrap="none" rtlCol="0">
-            <a:spAutoFit/>
-          </a:bodyPr>
-          <a:lstStyle/>
-          <a:p>
-            <a:r>
-              <a:rPr lang="en-TH" b="1" dirty="0">
-                <a:latin typeface="Roboto Mono" pitchFamily="49" charset="0"/>
-                <a:ea typeface="Roboto Mono" pitchFamily="49" charset="0"/>
-              </a:rPr>
-              <a:t>Sentinel</a:t>
-            </a:r>
-          </a:p>
-        </p:txBody>
-      </p:sp>
     </p:spTree>
     <p:extLst>
       <p:ext uri="{BB962C8B-B14F-4D97-AF65-F5344CB8AC3E}">
@@ -4710,7 +3586,7 @@
 <file path=ppt/theme/theme1.xml><?xml version="1.0" encoding="utf-8"?>
 <a:theme xmlns:a="http://schemas.openxmlformats.org/drawingml/2006/main" name="Office Theme">
   <a:themeElements>
-    <a:clrScheme name="Office">
+    <a:clrScheme name="Office Theme">
       <a:dk1>
         <a:sysClr val="windowText" lastClr="000000"/>
       </a:dk1>
@@ -4748,7 +3624,7 @@
         <a:srgbClr val="96607D"/>
       </a:folHlink>
     </a:clrScheme>
-    <a:fontScheme name="Office">
+    <a:fontScheme name="Office Theme">
       <a:majorFont>
         <a:latin typeface="Aptos Display" panose="02110004020202020204"/>
         <a:ea typeface=""/>
@@ -4854,7 +3730,7 @@
         <a:font script="Tfng" typeface="Ebrima"/>
       </a:minorFont>
     </a:fontScheme>
-    <a:fmtScheme name="Office">
+    <a:fmtScheme name="Office Theme">
       <a:fillStyleLst>
         <a:solidFill>
           <a:schemeClr val="phClr"/>

</xml_diff>